<commit_message>
Clarify tau2-bench issue distribution and tool counts
</commit_message>
<xml_diff>
--- a/slides/datasets-in-10-minutes-tau2-bench.pptx
+++ b/slides/datasets-in-10-minutes-tau2-bench.pptx
@@ -27778,7 +27778,7 @@
                 <a:ea typeface="Noto Sans CJK JP"/>
                 <a:cs typeface="Noto Sans"/>
               </a:rPr>
-              <a:t>通信課題に含まれる基本問題数（2〜5）</a:t>
+              <a:t>1課題に組み合わせた不具合の数（2〜5個）</a:t>
             </a:r>
           </a:p>
         </p:txBody>
@@ -27841,1535 +27841,14 @@
         </p:nvGraphicFramePr>
         <p:xfrm>
           <a:off x="548640" y="1508760"/>
-          <a:ext cx="8046720" cy="2852928"/>
+          <a:ext cx="8046720" cy="2304288"/>
         </p:xfrm>
         <a:graphic>
           <a:graphicData uri="http://schemas.openxmlformats.org/drawingml/2006/table">
             <a:tbl>
               <a:tblPr firstRow="0" bandRow="0"/>
               <a:tblGrid>
-                <a:gridCol w="5669280"/>
-                <a:gridCol w="2377440"/>
-              </a:tblGrid>
-              <a:tr h="475488">
-                <a:tc>
-                  <a:txBody>
-                    <a:bodyPr wrap="square">
-                      <a:noAutofit/>
-                    </a:bodyPr>
-                    <a:lstStyle/>
-                    <a:p>
-                      <a:pPr algn="l">
-                        <a:lnSpc>
-                          <a:spcPts val="2300"/>
-                        </a:lnSpc>
-                        <a:buNone/>
-                        <a:defRPr sz="2000" b="0">
-                          <a:solidFill>
-                            <a:srgbClr val="303437"/>
-                          </a:solidFill>
-                          <a:latin typeface="Noto Sans"/>
-                        </a:defRPr>
-                      </a:pPr>
-                      <a:r>
-                        <a:rPr sz="2000" b="0" lang="ja-JP" altLang="en-US">
-                          <a:solidFill>
-                            <a:srgbClr val="303437"/>
-                          </a:solidFill>
-                          <a:latin typeface="Noto Sans"/>
-                          <a:ea typeface="Noto Sans CJK JP"/>
-                          <a:cs typeface="Noto Sans"/>
-                        </a:rPr>
-                        <a:t>基本問題の数</a:t>
-                      </a:r>
-                    </a:p>
-                  </a:txBody>
-                  <a:tcPr marL="63500" marR="63500" marT="38100" marB="38100" anchor="ctr">
-                    <a:lnL w="7620">
-                      <a:noFill/>
-                    </a:lnL>
-                    <a:lnR w="7620">
-                      <a:noFill/>
-                    </a:lnR>
-                    <a:lnT w="15240">
-                      <a:solidFill>
-                        <a:srgbClr val="626669"/>
-                      </a:solidFill>
-                      <a:prstDash val="solid"/>
-                    </a:lnT>
-                    <a:lnB w="7620">
-                      <a:solidFill>
-                        <a:srgbClr val="626669"/>
-                      </a:solidFill>
-                      <a:prstDash val="solid"/>
-                    </a:lnB>
-                    <a:solidFill>
-                      <a:srgbClr val="FFFEF8"/>
-                    </a:solidFill>
-                  </a:tcPr>
-                </a:tc>
-                <a:tc>
-                  <a:txBody>
-                    <a:bodyPr wrap="square">
-                      <a:noAutofit/>
-                    </a:bodyPr>
-                    <a:lstStyle/>
-                    <a:p>
-                      <a:pPr algn="r">
-                        <a:lnSpc>
-                          <a:spcPts val="2300"/>
-                        </a:lnSpc>
-                        <a:buNone/>
-                        <a:defRPr sz="2000" b="0">
-                          <a:solidFill>
-                            <a:srgbClr val="303437"/>
-                          </a:solidFill>
-                          <a:latin typeface="Noto Sans"/>
-                        </a:defRPr>
-                      </a:pPr>
-                      <a:r>
-                        <a:rPr sz="2000" b="0" lang="ja-JP" altLang="en-US">
-                          <a:solidFill>
-                            <a:srgbClr val="303437"/>
-                          </a:solidFill>
-                          <a:latin typeface="Noto Sans"/>
-                          <a:ea typeface="Noto Sans CJK JP"/>
-                          <a:cs typeface="Noto Sans"/>
-                        </a:rPr>
-                        <a:t>課題数</a:t>
-                      </a:r>
-                    </a:p>
-                  </a:txBody>
-                  <a:tcPr marL="63500" marR="63500" marT="38100" marB="38100" anchor="ctr">
-                    <a:lnL w="7620">
-                      <a:noFill/>
-                    </a:lnL>
-                    <a:lnR w="7620">
-                      <a:noFill/>
-                    </a:lnR>
-                    <a:lnT w="15240">
-                      <a:solidFill>
-                        <a:srgbClr val="626669"/>
-                      </a:solidFill>
-                      <a:prstDash val="solid"/>
-                    </a:lnT>
-                    <a:lnB w="7620">
-                      <a:solidFill>
-                        <a:srgbClr val="626669"/>
-                      </a:solidFill>
-                      <a:prstDash val="solid"/>
-                    </a:lnB>
-                    <a:solidFill>
-                      <a:srgbClr val="FFFEF8"/>
-                    </a:solidFill>
-                  </a:tcPr>
-                </a:tc>
-              </a:tr>
-              <a:tr h="594360">
-                <a:tc>
-                  <a:txBody>
-                    <a:bodyPr wrap="square">
-                      <a:noAutofit/>
-                    </a:bodyPr>
-                    <a:lstStyle/>
-                    <a:p>
-                      <a:pPr algn="l">
-                        <a:lnSpc>
-                          <a:spcPts val="2300"/>
-                        </a:lnSpc>
-                        <a:buNone/>
-                        <a:defRPr sz="2000" b="0">
-                          <a:solidFill>
-                            <a:srgbClr val="303437"/>
-                          </a:solidFill>
-                          <a:latin typeface="Noto Sans"/>
-                        </a:defRPr>
-                      </a:pPr>
-                      <a:r>
-                        <a:rPr sz="2000" b="0" lang="ja-JP" altLang="en-US">
-                          <a:solidFill>
-                            <a:srgbClr val="303437"/>
-                          </a:solidFill>
-                          <a:latin typeface="Noto Sans"/>
-                          <a:ea typeface="Noto Sans CJK JP"/>
-                          <a:cs typeface="Noto Sans"/>
-                        </a:rPr>
-                        <a:t>2</a:t>
-                      </a:r>
-                    </a:p>
-                  </a:txBody>
-                  <a:tcPr marL="63500" marR="63500" marT="38100" marB="38100" anchor="ctr">
-                    <a:lnL w="7620">
-                      <a:noFill/>
-                    </a:lnL>
-                    <a:lnR w="7620">
-                      <a:noFill/>
-                    </a:lnR>
-                    <a:lnT w="7620">
-                      <a:solidFill>
-                        <a:srgbClr val="626669"/>
-                      </a:solidFill>
-                      <a:prstDash val="solid"/>
-                    </a:lnT>
-                    <a:lnB w="7620">
-                      <a:noFill/>
-                    </a:lnB>
-                    <a:solidFill>
-                      <a:srgbClr val="FFFEF8"/>
-                    </a:solidFill>
-                  </a:tcPr>
-                </a:tc>
-                <a:tc>
-                  <a:txBody>
-                    <a:bodyPr wrap="square">
-                      <a:noAutofit/>
-                    </a:bodyPr>
-                    <a:lstStyle/>
-                    <a:p>
-                      <a:pPr algn="r">
-                        <a:lnSpc>
-                          <a:spcPts val="2300"/>
-                        </a:lnSpc>
-                        <a:buNone/>
-                        <a:defRPr sz="2000" b="0">
-                          <a:solidFill>
-                            <a:srgbClr val="303437"/>
-                          </a:solidFill>
-                          <a:latin typeface="Noto Sans"/>
-                        </a:defRPr>
-                      </a:pPr>
-                      <a:r>
-                        <a:rPr sz="2000" b="0" lang="ja-JP" altLang="en-US">
-                          <a:solidFill>
-                            <a:srgbClr val="303437"/>
-                          </a:solidFill>
-                          <a:latin typeface="Noto Sans"/>
-                          <a:ea typeface="Noto Sans CJK JP"/>
-                          <a:cs typeface="Noto Sans"/>
-                        </a:rPr>
-                        <a:t>25</a:t>
-                      </a:r>
-                    </a:p>
-                  </a:txBody>
-                  <a:tcPr marL="63500" marR="63500" marT="38100" marB="38100" anchor="ctr">
-                    <a:lnL w="7620">
-                      <a:noFill/>
-                    </a:lnL>
-                    <a:lnR w="7620">
-                      <a:noFill/>
-                    </a:lnR>
-                    <a:lnT w="7620">
-                      <a:solidFill>
-                        <a:srgbClr val="626669"/>
-                      </a:solidFill>
-                      <a:prstDash val="solid"/>
-                    </a:lnT>
-                    <a:lnB w="7620">
-                      <a:noFill/>
-                    </a:lnB>
-                    <a:solidFill>
-                      <a:srgbClr val="FFFEF8"/>
-                    </a:solidFill>
-                  </a:tcPr>
-                </a:tc>
-              </a:tr>
-              <a:tr h="594360">
-                <a:tc>
-                  <a:txBody>
-                    <a:bodyPr wrap="square">
-                      <a:noAutofit/>
-                    </a:bodyPr>
-                    <a:lstStyle/>
-                    <a:p>
-                      <a:pPr algn="l">
-                        <a:lnSpc>
-                          <a:spcPts val="2300"/>
-                        </a:lnSpc>
-                        <a:buNone/>
-                        <a:defRPr sz="2000" b="0">
-                          <a:solidFill>
-                            <a:srgbClr val="303437"/>
-                          </a:solidFill>
-                          <a:latin typeface="Noto Sans"/>
-                        </a:defRPr>
-                      </a:pPr>
-                      <a:r>
-                        <a:rPr sz="2000" b="0" lang="ja-JP" altLang="en-US">
-                          <a:solidFill>
-                            <a:srgbClr val="303437"/>
-                          </a:solidFill>
-                          <a:latin typeface="Noto Sans"/>
-                          <a:ea typeface="Noto Sans CJK JP"/>
-                          <a:cs typeface="Noto Sans"/>
-                        </a:rPr>
-                        <a:t>3</a:t>
-                      </a:r>
-                    </a:p>
-                  </a:txBody>
-                  <a:tcPr marL="63500" marR="63500" marT="38100" marB="38100" anchor="ctr">
-                    <a:lnL w="7620">
-                      <a:noFill/>
-                    </a:lnL>
-                    <a:lnR w="7620">
-                      <a:noFill/>
-                    </a:lnR>
-                    <a:lnT w="7620">
-                      <a:noFill/>
-                    </a:lnT>
-                    <a:lnB w="7620">
-                      <a:noFill/>
-                    </a:lnB>
-                    <a:solidFill>
-                      <a:srgbClr val="FFFEF8"/>
-                    </a:solidFill>
-                  </a:tcPr>
-                </a:tc>
-                <a:tc>
-                  <a:txBody>
-                    <a:bodyPr wrap="square">
-                      <a:noAutofit/>
-                    </a:bodyPr>
-                    <a:lstStyle/>
-                    <a:p>
-                      <a:pPr algn="r">
-                        <a:lnSpc>
-                          <a:spcPts val="2300"/>
-                        </a:lnSpc>
-                        <a:buNone/>
-                        <a:defRPr sz="2000" b="0">
-                          <a:solidFill>
-                            <a:srgbClr val="303437"/>
-                          </a:solidFill>
-                          <a:latin typeface="Noto Sans"/>
-                        </a:defRPr>
-                      </a:pPr>
-                      <a:r>
-                        <a:rPr sz="2000" b="0" lang="ja-JP" altLang="en-US">
-                          <a:solidFill>
-                            <a:srgbClr val="303437"/>
-                          </a:solidFill>
-                          <a:latin typeface="Noto Sans"/>
-                          <a:ea typeface="Noto Sans CJK JP"/>
-                          <a:cs typeface="Noto Sans"/>
-                        </a:rPr>
-                        <a:t>26</a:t>
-                      </a:r>
-                    </a:p>
-                  </a:txBody>
-                  <a:tcPr marL="63500" marR="63500" marT="38100" marB="38100" anchor="ctr">
-                    <a:lnL w="7620">
-                      <a:noFill/>
-                    </a:lnL>
-                    <a:lnR w="7620">
-                      <a:noFill/>
-                    </a:lnR>
-                    <a:lnT w="7620">
-                      <a:noFill/>
-                    </a:lnT>
-                    <a:lnB w="7620">
-                      <a:noFill/>
-                    </a:lnB>
-                    <a:solidFill>
-                      <a:srgbClr val="FFFEF8"/>
-                    </a:solidFill>
-                  </a:tcPr>
-                </a:tc>
-              </a:tr>
-              <a:tr h="594360">
-                <a:tc>
-                  <a:txBody>
-                    <a:bodyPr wrap="square">
-                      <a:noAutofit/>
-                    </a:bodyPr>
-                    <a:lstStyle/>
-                    <a:p>
-                      <a:pPr algn="l">
-                        <a:lnSpc>
-                          <a:spcPts val="2300"/>
-                        </a:lnSpc>
-                        <a:buNone/>
-                        <a:defRPr sz="2000" b="0">
-                          <a:solidFill>
-                            <a:srgbClr val="303437"/>
-                          </a:solidFill>
-                          <a:latin typeface="Noto Sans"/>
-                        </a:defRPr>
-                      </a:pPr>
-                      <a:r>
-                        <a:rPr sz="2000" b="0" lang="ja-JP" altLang="en-US">
-                          <a:solidFill>
-                            <a:srgbClr val="303437"/>
-                          </a:solidFill>
-                          <a:latin typeface="Noto Sans"/>
-                          <a:ea typeface="Noto Sans CJK JP"/>
-                          <a:cs typeface="Noto Sans"/>
-                        </a:rPr>
-                        <a:t>4</a:t>
-                      </a:r>
-                    </a:p>
-                  </a:txBody>
-                  <a:tcPr marL="63500" marR="63500" marT="38100" marB="38100" anchor="ctr">
-                    <a:lnL w="7620">
-                      <a:noFill/>
-                    </a:lnL>
-                    <a:lnR w="7620">
-                      <a:noFill/>
-                    </a:lnR>
-                    <a:lnT w="7620">
-                      <a:noFill/>
-                    </a:lnT>
-                    <a:lnB w="7620">
-                      <a:noFill/>
-                    </a:lnB>
-                    <a:solidFill>
-                      <a:srgbClr val="FFFEF8"/>
-                    </a:solidFill>
-                  </a:tcPr>
-                </a:tc>
-                <a:tc>
-                  <a:txBody>
-                    <a:bodyPr wrap="square">
-                      <a:noAutofit/>
-                    </a:bodyPr>
-                    <a:lstStyle/>
-                    <a:p>
-                      <a:pPr algn="r">
-                        <a:lnSpc>
-                          <a:spcPts val="2300"/>
-                        </a:lnSpc>
-                        <a:buNone/>
-                        <a:defRPr sz="2000" b="0">
-                          <a:solidFill>
-                            <a:srgbClr val="303437"/>
-                          </a:solidFill>
-                          <a:latin typeface="Noto Sans"/>
-                        </a:defRPr>
-                      </a:pPr>
-                      <a:r>
-                        <a:rPr sz="2000" b="0" lang="ja-JP" altLang="en-US">
-                          <a:solidFill>
-                            <a:srgbClr val="303437"/>
-                          </a:solidFill>
-                          <a:latin typeface="Noto Sans"/>
-                          <a:ea typeface="Noto Sans CJK JP"/>
-                          <a:cs typeface="Noto Sans"/>
-                        </a:rPr>
-                        <a:t>21</a:t>
-                      </a:r>
-                    </a:p>
-                  </a:txBody>
-                  <a:tcPr marL="63500" marR="63500" marT="38100" marB="38100" anchor="ctr">
-                    <a:lnL w="7620">
-                      <a:noFill/>
-                    </a:lnL>
-                    <a:lnR w="7620">
-                      <a:noFill/>
-                    </a:lnR>
-                    <a:lnT w="7620">
-                      <a:noFill/>
-                    </a:lnT>
-                    <a:lnB w="7620">
-                      <a:noFill/>
-                    </a:lnB>
-                    <a:solidFill>
-                      <a:srgbClr val="FFFEF8"/>
-                    </a:solidFill>
-                  </a:tcPr>
-                </a:tc>
-              </a:tr>
-              <a:tr h="594360">
-                <a:tc>
-                  <a:txBody>
-                    <a:bodyPr wrap="square">
-                      <a:noAutofit/>
-                    </a:bodyPr>
-                    <a:lstStyle/>
-                    <a:p>
-                      <a:pPr algn="l">
-                        <a:lnSpc>
-                          <a:spcPts val="2300"/>
-                        </a:lnSpc>
-                        <a:buNone/>
-                        <a:defRPr sz="2000" b="0">
-                          <a:solidFill>
-                            <a:srgbClr val="303437"/>
-                          </a:solidFill>
-                          <a:latin typeface="Noto Sans"/>
-                        </a:defRPr>
-                      </a:pPr>
-                      <a:r>
-                        <a:rPr sz="2000" b="0" lang="ja-JP" altLang="en-US">
-                          <a:solidFill>
-                            <a:srgbClr val="303437"/>
-                          </a:solidFill>
-                          <a:latin typeface="Noto Sans"/>
-                          <a:ea typeface="Noto Sans CJK JP"/>
-                          <a:cs typeface="Noto Sans"/>
-                        </a:rPr>
-                        <a:t>5</a:t>
-                      </a:r>
-                    </a:p>
-                  </a:txBody>
-                  <a:tcPr marL="63500" marR="63500" marT="38100" marB="38100" anchor="ctr">
-                    <a:lnL w="7620">
-                      <a:noFill/>
-                    </a:lnL>
-                    <a:lnR w="7620">
-                      <a:noFill/>
-                    </a:lnR>
-                    <a:lnT w="7620">
-                      <a:noFill/>
-                    </a:lnT>
-                    <a:lnB w="15240">
-                      <a:solidFill>
-                        <a:srgbClr val="626669"/>
-                      </a:solidFill>
-                      <a:prstDash val="solid"/>
-                    </a:lnB>
-                    <a:solidFill>
-                      <a:srgbClr val="FFFEF8"/>
-                    </a:solidFill>
-                  </a:tcPr>
-                </a:tc>
-                <a:tc>
-                  <a:txBody>
-                    <a:bodyPr wrap="square">
-                      <a:noAutofit/>
-                    </a:bodyPr>
-                    <a:lstStyle/>
-                    <a:p>
-                      <a:pPr algn="r">
-                        <a:lnSpc>
-                          <a:spcPts val="2300"/>
-                        </a:lnSpc>
-                        <a:buNone/>
-                        <a:defRPr sz="2000" b="0">
-                          <a:solidFill>
-                            <a:srgbClr val="303437"/>
-                          </a:solidFill>
-                          <a:latin typeface="Noto Sans"/>
-                        </a:defRPr>
-                      </a:pPr>
-                      <a:r>
-                        <a:rPr sz="2000" b="0" lang="ja-JP" altLang="en-US">
-                          <a:solidFill>
-                            <a:srgbClr val="303437"/>
-                          </a:solidFill>
-                          <a:latin typeface="Noto Sans"/>
-                          <a:ea typeface="Noto Sans CJK JP"/>
-                          <a:cs typeface="Noto Sans"/>
-                        </a:rPr>
-                        <a:t>13</a:t>
-                      </a:r>
-                    </a:p>
-                  </a:txBody>
-                  <a:tcPr marL="63500" marR="63500" marT="38100" marB="38100" anchor="ctr">
-                    <a:lnL w="7620">
-                      <a:noFill/>
-                    </a:lnL>
-                    <a:lnR w="7620">
-                      <a:noFill/>
-                    </a:lnR>
-                    <a:lnT w="7620">
-                      <a:noFill/>
-                    </a:lnT>
-                    <a:lnB w="15240">
-                      <a:solidFill>
-                        <a:srgbClr val="626669"/>
-                      </a:solidFill>
-                      <a:prstDash val="solid"/>
-                    </a:lnB>
-                    <a:solidFill>
-                      <a:srgbClr val="FFFEF8"/>
-                    </a:solidFill>
-                  </a:tcPr>
-                </a:tc>
-              </a:tr>
-            </a:tbl>
-          </a:graphicData>
-        </a:graphic>
-      </p:graphicFrame>
-      <p:sp>
-        <p:nvSpPr>
-          <p:cNvPr id="5" name="TextBox 4"/>
-          <p:cNvSpPr txBox="1"/>
-          <p:nvPr/>
-        </p:nvSpPr>
-        <p:spPr>
-          <a:xfrm>
-            <a:off x="502920" y="4690872"/>
-            <a:ext cx="8183879" cy="393192"/>
-          </a:xfrm>
-          <a:prstGeom prst="rect">
-            <a:avLst/>
-          </a:prstGeom>
-          <a:noFill/>
-        </p:spPr>
-        <p:txBody>
-          <a:bodyPr wrap="square" lIns="0" rIns="0" tIns="0" bIns="0">
-            <a:noAutofit/>
-          </a:bodyPr>
-          <a:lstStyle/>
-          <a:p>
-            <a:pPr algn="l">
-              <a:lnSpc>
-                <a:spcPct val="112000"/>
-              </a:lnSpc>
-              <a:spcBef>
-                <a:spcPts val="0"/>
-              </a:spcBef>
-              <a:spcAft>
-                <a:spcPts val="0"/>
-              </a:spcAft>
-              <a:buNone/>
-              <a:defRPr sz="810" b="0">
-                <a:solidFill>
-                  <a:srgbClr val="303437"/>
-                </a:solidFill>
-                <a:latin typeface="Noto Sans"/>
-              </a:defRPr>
-            </a:pPr>
-            <a:r>
-              <a:rPr sz="810" b="0" lang="ja-JP" altLang="en-US">
-                <a:solidFill>
-                  <a:srgbClr val="626669"/>
-                </a:solidFill>
-                <a:latin typeface="Noto Sans"/>
-                <a:ea typeface="Noto Sans CJK JP"/>
-                <a:cs typeface="Noto Sans"/>
-              </a:rPr>
-              <a:t/>
-            </a:r>
-            <a:r>
-              <a:rPr sz="810" b="0" lang="ja-JP" altLang="en-US">
-                <a:solidFill>
-                  <a:srgbClr val="626669"/>
-                </a:solidFill>
-                <a:latin typeface="Noto Sans"/>
-                <a:ea typeface="Noto Sans CJK JP"/>
-                <a:cs typeface="Noto Sans"/>
-              </a:rPr>
-              <a:t>Sierra (2025). τ²-bench. 公開版v0.2.0、278課題。2026-10-16集計。</a:t>
-            </a:r>
-            <a:r>
-              <a:rPr sz="810" b="0" lang="ja-JP" altLang="en-US">
-                <a:solidFill>
-                  <a:srgbClr val="626669"/>
-                </a:solidFill>
-                <a:latin typeface="Noto Sans"/>
-                <a:ea typeface="Noto Sans CJK JP"/>
-                <a:cs typeface="Noto Sans"/>
-              </a:rPr>
-              <a:t>  </a:t>
-            </a:r>
-            <a:r>
-              <a:rPr sz="810" b="0" lang="ja-JP" altLang="en-US">
-                <a:solidFill>
-                  <a:srgbClr val="626669"/>
-                </a:solidFill>
-                <a:latin typeface="Noto Sans"/>
-                <a:ea typeface="Noto Sans CJK JP"/>
-                <a:cs typeface="Noto Sans"/>
-                <a:hlinkClick r:id="rId2"/>
-              </a:rPr>
-              <a:t>https://github.com/sierra-research/tau2-bench/tree/v0.2.0/data/tau2/domains</a:t>
-            </a:r>
-          </a:p>
-        </p:txBody>
-      </p:sp>
-    </p:spTree>
-  </p:cSld>
-  <p:clrMapOvr>
-    <a:masterClrMapping/>
-  </p:clrMapOvr>
-</p:sld>
-</file>
-
-<file path=ppt/slides/slide55.xml><?xml version="1.0" encoding="utf-8"?>
-<p:sld xmlns:a="http://schemas.openxmlformats.org/drawingml/2006/main" xmlns:p="http://schemas.openxmlformats.org/presentationml/2006/main" xmlns:r="http://schemas.openxmlformats.org/officeDocument/2006/relationships">
-  <p:cSld>
-    <p:spTree>
-      <p:nvGrpSpPr>
-        <p:cNvPr id="1" name=""/>
-        <p:cNvGrpSpPr/>
-        <p:nvPr/>
-      </p:nvGrpSpPr>
-      <p:grpSpPr/>
-      <p:sp>
-        <p:nvSpPr>
-          <p:cNvPr id="2" name="Title 1"/>
-          <p:cNvSpPr>
-            <a:spLocks noGrp="1"/>
-          </p:cNvSpPr>
-          <p:nvPr>
-            <p:ph type="title"/>
-          </p:nvPr>
-        </p:nvSpPr>
-        <p:spPr>
-          <a:xfrm>
-            <a:off x="548640" y="786384"/>
-            <a:ext cx="8046720" cy="502920"/>
-          </a:xfrm>
-        </p:spPr>
-        <p:txBody>
-          <a:bodyPr wrap="square" lIns="0" rIns="0" tIns="0" bIns="0">
-            <a:noAutofit/>
-          </a:bodyPr>
-          <a:lstStyle/>
-          <a:p>
-            <a:pPr algn="l">
-              <a:lnSpc>
-                <a:spcPct val="110000"/>
-              </a:lnSpc>
-              <a:buNone/>
-              <a:defRPr sz="2800" b="0">
-                <a:solidFill>
-                  <a:srgbClr val="303437"/>
-                </a:solidFill>
-                <a:latin typeface="Noto Sans"/>
-              </a:defRPr>
-            </a:pPr>
-            <a:r>
-              <a:rPr sz="2800" b="1" lang="ja-JP" altLang="en-US">
-                <a:solidFill>
-                  <a:srgbClr val="303437"/>
-                </a:solidFill>
-                <a:latin typeface="Noto Sans"/>
-                <a:ea typeface="Noto Sans CJK JP"/>
-                <a:cs typeface="Noto Sans"/>
-              </a:rPr>
-              <a:t>通信課題に含まれる基本問題数（6〜9）</a:t>
-            </a:r>
-          </a:p>
-        </p:txBody>
-      </p:sp>
-      <p:sp>
-        <p:nvSpPr>
-          <p:cNvPr id="3" name="Title 2"/>
-          <p:cNvSpPr>
-            <a:spLocks noGrp="1"/>
-          </p:cNvSpPr>
-          <p:nvPr>
-            <p:ph type="title" idx="2"/>
-          </p:nvPr>
-        </p:nvSpPr>
-        <p:spPr>
-          <a:xfrm>
-            <a:off x="75895" y="0"/>
-            <a:ext cx="8115300" cy="480060"/>
-          </a:xfrm>
-        </p:spPr>
-        <p:txBody>
-          <a:bodyPr wrap="square" lIns="0" rIns="0" tIns="0" bIns="0" anchor="ctr">
-            <a:noAutofit/>
-          </a:bodyPr>
-          <a:lstStyle/>
-          <a:p>
-            <a:pPr algn="l">
-              <a:lnSpc>
-                <a:spcPct val="110000"/>
-              </a:lnSpc>
-              <a:buNone/>
-              <a:defRPr sz="1400" b="0">
-                <a:solidFill>
-                  <a:srgbClr val="303437"/>
-                </a:solidFill>
-                <a:latin typeface="Noto Sans"/>
-              </a:defRPr>
-            </a:pPr>
-            <a:r>
-              <a:rPr sz="1400" b="1" lang="ja-JP" altLang="en-US">
-                <a:solidFill>
-                  <a:srgbClr val="FFFFFF"/>
-                </a:solidFill>
-                <a:latin typeface="Noto Sans"/>
-                <a:ea typeface="Noto Sans CJK JP"/>
-                <a:cs typeface="Noto Sans"/>
-              </a:rPr>
-              <a:t>Appendix: 2. 指標・版・公開データ</a:t>
-            </a:r>
-          </a:p>
-        </p:txBody>
-      </p:sp>
-      <p:graphicFrame>
-        <p:nvGraphicFramePr>
-          <p:cNvPr id="4" name="Table 3"/>
-          <p:cNvGraphicFramePr>
-            <a:graphicFrameLocks noGrp="1"/>
-          </p:cNvGraphicFramePr>
-          <p:nvPr/>
-        </p:nvGraphicFramePr>
-        <p:xfrm>
-          <a:off x="548640" y="1508760"/>
-          <a:ext cx="8046720" cy="2852928"/>
-        </p:xfrm>
-        <a:graphic>
-          <a:graphicData uri="http://schemas.openxmlformats.org/drawingml/2006/table">
-            <a:tbl>
-              <a:tblPr firstRow="0" bandRow="0"/>
-              <a:tblGrid>
-                <a:gridCol w="5669280"/>
-                <a:gridCol w="2377440"/>
-              </a:tblGrid>
-              <a:tr h="475488">
-                <a:tc>
-                  <a:txBody>
-                    <a:bodyPr wrap="square">
-                      <a:noAutofit/>
-                    </a:bodyPr>
-                    <a:lstStyle/>
-                    <a:p>
-                      <a:pPr algn="l">
-                        <a:lnSpc>
-                          <a:spcPts val="2300"/>
-                        </a:lnSpc>
-                        <a:buNone/>
-                        <a:defRPr sz="2000" b="0">
-                          <a:solidFill>
-                            <a:srgbClr val="303437"/>
-                          </a:solidFill>
-                          <a:latin typeface="Noto Sans"/>
-                        </a:defRPr>
-                      </a:pPr>
-                      <a:r>
-                        <a:rPr sz="2000" b="0" lang="ja-JP" altLang="en-US">
-                          <a:solidFill>
-                            <a:srgbClr val="303437"/>
-                          </a:solidFill>
-                          <a:latin typeface="Noto Sans"/>
-                          <a:ea typeface="Noto Sans CJK JP"/>
-                          <a:cs typeface="Noto Sans"/>
-                        </a:rPr>
-                        <a:t>基本問題の数</a:t>
-                      </a:r>
-                    </a:p>
-                  </a:txBody>
-                  <a:tcPr marL="63500" marR="63500" marT="38100" marB="38100" anchor="ctr">
-                    <a:lnL w="7620">
-                      <a:noFill/>
-                    </a:lnL>
-                    <a:lnR w="7620">
-                      <a:noFill/>
-                    </a:lnR>
-                    <a:lnT w="15240">
-                      <a:solidFill>
-                        <a:srgbClr val="626669"/>
-                      </a:solidFill>
-                      <a:prstDash val="solid"/>
-                    </a:lnT>
-                    <a:lnB w="7620">
-                      <a:solidFill>
-                        <a:srgbClr val="626669"/>
-                      </a:solidFill>
-                      <a:prstDash val="solid"/>
-                    </a:lnB>
-                    <a:solidFill>
-                      <a:srgbClr val="FFFEF8"/>
-                    </a:solidFill>
-                  </a:tcPr>
-                </a:tc>
-                <a:tc>
-                  <a:txBody>
-                    <a:bodyPr wrap="square">
-                      <a:noAutofit/>
-                    </a:bodyPr>
-                    <a:lstStyle/>
-                    <a:p>
-                      <a:pPr algn="r">
-                        <a:lnSpc>
-                          <a:spcPts val="2300"/>
-                        </a:lnSpc>
-                        <a:buNone/>
-                        <a:defRPr sz="2000" b="0">
-                          <a:solidFill>
-                            <a:srgbClr val="303437"/>
-                          </a:solidFill>
-                          <a:latin typeface="Noto Sans"/>
-                        </a:defRPr>
-                      </a:pPr>
-                      <a:r>
-                        <a:rPr sz="2000" b="0" lang="ja-JP" altLang="en-US">
-                          <a:solidFill>
-                            <a:srgbClr val="303437"/>
-                          </a:solidFill>
-                          <a:latin typeface="Noto Sans"/>
-                          <a:ea typeface="Noto Sans CJK JP"/>
-                          <a:cs typeface="Noto Sans"/>
-                        </a:rPr>
-                        <a:t>課題数</a:t>
-                      </a:r>
-                    </a:p>
-                  </a:txBody>
-                  <a:tcPr marL="63500" marR="63500" marT="38100" marB="38100" anchor="ctr">
-                    <a:lnL w="7620">
-                      <a:noFill/>
-                    </a:lnL>
-                    <a:lnR w="7620">
-                      <a:noFill/>
-                    </a:lnR>
-                    <a:lnT w="15240">
-                      <a:solidFill>
-                        <a:srgbClr val="626669"/>
-                      </a:solidFill>
-                      <a:prstDash val="solid"/>
-                    </a:lnT>
-                    <a:lnB w="7620">
-                      <a:solidFill>
-                        <a:srgbClr val="626669"/>
-                      </a:solidFill>
-                      <a:prstDash val="solid"/>
-                    </a:lnB>
-                    <a:solidFill>
-                      <a:srgbClr val="FFFEF8"/>
-                    </a:solidFill>
-                  </a:tcPr>
-                </a:tc>
-              </a:tr>
-              <a:tr h="594360">
-                <a:tc>
-                  <a:txBody>
-                    <a:bodyPr wrap="square">
-                      <a:noAutofit/>
-                    </a:bodyPr>
-                    <a:lstStyle/>
-                    <a:p>
-                      <a:pPr algn="l">
-                        <a:lnSpc>
-                          <a:spcPts val="2300"/>
-                        </a:lnSpc>
-                        <a:buNone/>
-                        <a:defRPr sz="2000" b="0">
-                          <a:solidFill>
-                            <a:srgbClr val="303437"/>
-                          </a:solidFill>
-                          <a:latin typeface="Noto Sans"/>
-                        </a:defRPr>
-                      </a:pPr>
-                      <a:r>
-                        <a:rPr sz="2000" b="0" lang="ja-JP" altLang="en-US">
-                          <a:solidFill>
-                            <a:srgbClr val="303437"/>
-                          </a:solidFill>
-                          <a:latin typeface="Noto Sans"/>
-                          <a:ea typeface="Noto Sans CJK JP"/>
-                          <a:cs typeface="Noto Sans"/>
-                        </a:rPr>
-                        <a:t>6</a:t>
-                      </a:r>
-                    </a:p>
-                  </a:txBody>
-                  <a:tcPr marL="63500" marR="63500" marT="38100" marB="38100" anchor="ctr">
-                    <a:lnL w="7620">
-                      <a:noFill/>
-                    </a:lnL>
-                    <a:lnR w="7620">
-                      <a:noFill/>
-                    </a:lnR>
-                    <a:lnT w="7620">
-                      <a:solidFill>
-                        <a:srgbClr val="626669"/>
-                      </a:solidFill>
-                      <a:prstDash val="solid"/>
-                    </a:lnT>
-                    <a:lnB w="7620">
-                      <a:noFill/>
-                    </a:lnB>
-                    <a:solidFill>
-                      <a:srgbClr val="FFFEF8"/>
-                    </a:solidFill>
-                  </a:tcPr>
-                </a:tc>
-                <a:tc>
-                  <a:txBody>
-                    <a:bodyPr wrap="square">
-                      <a:noAutofit/>
-                    </a:bodyPr>
-                    <a:lstStyle/>
-                    <a:p>
-                      <a:pPr algn="r">
-                        <a:lnSpc>
-                          <a:spcPts val="2300"/>
-                        </a:lnSpc>
-                        <a:buNone/>
-                        <a:defRPr sz="2000" b="0">
-                          <a:solidFill>
-                            <a:srgbClr val="303437"/>
-                          </a:solidFill>
-                          <a:latin typeface="Noto Sans"/>
-                        </a:defRPr>
-                      </a:pPr>
-                      <a:r>
-                        <a:rPr sz="2000" b="0" lang="ja-JP" altLang="en-US">
-                          <a:solidFill>
-                            <a:srgbClr val="303437"/>
-                          </a:solidFill>
-                          <a:latin typeface="Noto Sans"/>
-                          <a:ea typeface="Noto Sans CJK JP"/>
-                          <a:cs typeface="Noto Sans"/>
-                        </a:rPr>
-                        <a:t>11</a:t>
-                      </a:r>
-                    </a:p>
-                  </a:txBody>
-                  <a:tcPr marL="63500" marR="63500" marT="38100" marB="38100" anchor="ctr">
-                    <a:lnL w="7620">
-                      <a:noFill/>
-                    </a:lnL>
-                    <a:lnR w="7620">
-                      <a:noFill/>
-                    </a:lnR>
-                    <a:lnT w="7620">
-                      <a:solidFill>
-                        <a:srgbClr val="626669"/>
-                      </a:solidFill>
-                      <a:prstDash val="solid"/>
-                    </a:lnT>
-                    <a:lnB w="7620">
-                      <a:noFill/>
-                    </a:lnB>
-                    <a:solidFill>
-                      <a:srgbClr val="FFFEF8"/>
-                    </a:solidFill>
-                  </a:tcPr>
-                </a:tc>
-              </a:tr>
-              <a:tr h="594360">
-                <a:tc>
-                  <a:txBody>
-                    <a:bodyPr wrap="square">
-                      <a:noAutofit/>
-                    </a:bodyPr>
-                    <a:lstStyle/>
-                    <a:p>
-                      <a:pPr algn="l">
-                        <a:lnSpc>
-                          <a:spcPts val="2300"/>
-                        </a:lnSpc>
-                        <a:buNone/>
-                        <a:defRPr sz="2000" b="0">
-                          <a:solidFill>
-                            <a:srgbClr val="303437"/>
-                          </a:solidFill>
-                          <a:latin typeface="Noto Sans"/>
-                        </a:defRPr>
-                      </a:pPr>
-                      <a:r>
-                        <a:rPr sz="2000" b="0" lang="ja-JP" altLang="en-US">
-                          <a:solidFill>
-                            <a:srgbClr val="303437"/>
-                          </a:solidFill>
-                          <a:latin typeface="Noto Sans"/>
-                          <a:ea typeface="Noto Sans CJK JP"/>
-                          <a:cs typeface="Noto Sans"/>
-                        </a:rPr>
-                        <a:t>7</a:t>
-                      </a:r>
-                    </a:p>
-                  </a:txBody>
-                  <a:tcPr marL="63500" marR="63500" marT="38100" marB="38100" anchor="ctr">
-                    <a:lnL w="7620">
-                      <a:noFill/>
-                    </a:lnL>
-                    <a:lnR w="7620">
-                      <a:noFill/>
-                    </a:lnR>
-                    <a:lnT w="7620">
-                      <a:noFill/>
-                    </a:lnT>
-                    <a:lnB w="7620">
-                      <a:noFill/>
-                    </a:lnB>
-                    <a:solidFill>
-                      <a:srgbClr val="FFFEF8"/>
-                    </a:solidFill>
-                  </a:tcPr>
-                </a:tc>
-                <a:tc>
-                  <a:txBody>
-                    <a:bodyPr wrap="square">
-                      <a:noAutofit/>
-                    </a:bodyPr>
-                    <a:lstStyle/>
-                    <a:p>
-                      <a:pPr algn="r">
-                        <a:lnSpc>
-                          <a:spcPts val="2300"/>
-                        </a:lnSpc>
-                        <a:buNone/>
-                        <a:defRPr sz="2000" b="0">
-                          <a:solidFill>
-                            <a:srgbClr val="303437"/>
-                          </a:solidFill>
-                          <a:latin typeface="Noto Sans"/>
-                        </a:defRPr>
-                      </a:pPr>
-                      <a:r>
-                        <a:rPr sz="2000" b="0" lang="ja-JP" altLang="en-US">
-                          <a:solidFill>
-                            <a:srgbClr val="303437"/>
-                          </a:solidFill>
-                          <a:latin typeface="Noto Sans"/>
-                          <a:ea typeface="Noto Sans CJK JP"/>
-                          <a:cs typeface="Noto Sans"/>
-                        </a:rPr>
-                        <a:t>8</a:t>
-                      </a:r>
-                    </a:p>
-                  </a:txBody>
-                  <a:tcPr marL="63500" marR="63500" marT="38100" marB="38100" anchor="ctr">
-                    <a:lnL w="7620">
-                      <a:noFill/>
-                    </a:lnL>
-                    <a:lnR w="7620">
-                      <a:noFill/>
-                    </a:lnR>
-                    <a:lnT w="7620">
-                      <a:noFill/>
-                    </a:lnT>
-                    <a:lnB w="7620">
-                      <a:noFill/>
-                    </a:lnB>
-                    <a:solidFill>
-                      <a:srgbClr val="FFFEF8"/>
-                    </a:solidFill>
-                  </a:tcPr>
-                </a:tc>
-              </a:tr>
-              <a:tr h="594360">
-                <a:tc>
-                  <a:txBody>
-                    <a:bodyPr wrap="square">
-                      <a:noAutofit/>
-                    </a:bodyPr>
-                    <a:lstStyle/>
-                    <a:p>
-                      <a:pPr algn="l">
-                        <a:lnSpc>
-                          <a:spcPts val="2300"/>
-                        </a:lnSpc>
-                        <a:buNone/>
-                        <a:defRPr sz="2000" b="0">
-                          <a:solidFill>
-                            <a:srgbClr val="303437"/>
-                          </a:solidFill>
-                          <a:latin typeface="Noto Sans"/>
-                        </a:defRPr>
-                      </a:pPr>
-                      <a:r>
-                        <a:rPr sz="2000" b="0" lang="ja-JP" altLang="en-US">
-                          <a:solidFill>
-                            <a:srgbClr val="303437"/>
-                          </a:solidFill>
-                          <a:latin typeface="Noto Sans"/>
-                          <a:ea typeface="Noto Sans CJK JP"/>
-                          <a:cs typeface="Noto Sans"/>
-                        </a:rPr>
-                        <a:t>8</a:t>
-                      </a:r>
-                    </a:p>
-                  </a:txBody>
-                  <a:tcPr marL="63500" marR="63500" marT="38100" marB="38100" anchor="ctr">
-                    <a:lnL w="7620">
-                      <a:noFill/>
-                    </a:lnL>
-                    <a:lnR w="7620">
-                      <a:noFill/>
-                    </a:lnR>
-                    <a:lnT w="7620">
-                      <a:noFill/>
-                    </a:lnT>
-                    <a:lnB w="7620">
-                      <a:noFill/>
-                    </a:lnB>
-                    <a:solidFill>
-                      <a:srgbClr val="FFFEF8"/>
-                    </a:solidFill>
-                  </a:tcPr>
-                </a:tc>
-                <a:tc>
-                  <a:txBody>
-                    <a:bodyPr wrap="square">
-                      <a:noAutofit/>
-                    </a:bodyPr>
-                    <a:lstStyle/>
-                    <a:p>
-                      <a:pPr algn="r">
-                        <a:lnSpc>
-                          <a:spcPts val="2300"/>
-                        </a:lnSpc>
-                        <a:buNone/>
-                        <a:defRPr sz="2000" b="0">
-                          <a:solidFill>
-                            <a:srgbClr val="303437"/>
-                          </a:solidFill>
-                          <a:latin typeface="Noto Sans"/>
-                        </a:defRPr>
-                      </a:pPr>
-                      <a:r>
-                        <a:rPr sz="2000" b="0" lang="ja-JP" altLang="en-US">
-                          <a:solidFill>
-                            <a:srgbClr val="303437"/>
-                          </a:solidFill>
-                          <a:latin typeface="Noto Sans"/>
-                          <a:ea typeface="Noto Sans CJK JP"/>
-                          <a:cs typeface="Noto Sans"/>
-                        </a:rPr>
-                        <a:t>4</a:t>
-                      </a:r>
-                    </a:p>
-                  </a:txBody>
-                  <a:tcPr marL="63500" marR="63500" marT="38100" marB="38100" anchor="ctr">
-                    <a:lnL w="7620">
-                      <a:noFill/>
-                    </a:lnL>
-                    <a:lnR w="7620">
-                      <a:noFill/>
-                    </a:lnR>
-                    <a:lnT w="7620">
-                      <a:noFill/>
-                    </a:lnT>
-                    <a:lnB w="7620">
-                      <a:noFill/>
-                    </a:lnB>
-                    <a:solidFill>
-                      <a:srgbClr val="FFFEF8"/>
-                    </a:solidFill>
-                  </a:tcPr>
-                </a:tc>
-              </a:tr>
-              <a:tr h="594360">
-                <a:tc>
-                  <a:txBody>
-                    <a:bodyPr wrap="square">
-                      <a:noAutofit/>
-                    </a:bodyPr>
-                    <a:lstStyle/>
-                    <a:p>
-                      <a:pPr algn="l">
-                        <a:lnSpc>
-                          <a:spcPts val="2300"/>
-                        </a:lnSpc>
-                        <a:buNone/>
-                        <a:defRPr sz="2000" b="0">
-                          <a:solidFill>
-                            <a:srgbClr val="303437"/>
-                          </a:solidFill>
-                          <a:latin typeface="Noto Sans"/>
-                        </a:defRPr>
-                      </a:pPr>
-                      <a:r>
-                        <a:rPr sz="2000" b="0" lang="ja-JP" altLang="en-US">
-                          <a:solidFill>
-                            <a:srgbClr val="303437"/>
-                          </a:solidFill>
-                          <a:latin typeface="Noto Sans"/>
-                          <a:ea typeface="Noto Sans CJK JP"/>
-                          <a:cs typeface="Noto Sans"/>
-                        </a:rPr>
-                        <a:t>9</a:t>
-                      </a:r>
-                    </a:p>
-                  </a:txBody>
-                  <a:tcPr marL="63500" marR="63500" marT="38100" marB="38100" anchor="ctr">
-                    <a:lnL w="7620">
-                      <a:noFill/>
-                    </a:lnL>
-                    <a:lnR w="7620">
-                      <a:noFill/>
-                    </a:lnR>
-                    <a:lnT w="7620">
-                      <a:noFill/>
-                    </a:lnT>
-                    <a:lnB w="15240">
-                      <a:solidFill>
-                        <a:srgbClr val="626669"/>
-                      </a:solidFill>
-                      <a:prstDash val="solid"/>
-                    </a:lnB>
-                    <a:solidFill>
-                      <a:srgbClr val="FFFEF8"/>
-                    </a:solidFill>
-                  </a:tcPr>
-                </a:tc>
-                <a:tc>
-                  <a:txBody>
-                    <a:bodyPr wrap="square">
-                      <a:noAutofit/>
-                    </a:bodyPr>
-                    <a:lstStyle/>
-                    <a:p>
-                      <a:pPr algn="r">
-                        <a:lnSpc>
-                          <a:spcPts val="2300"/>
-                        </a:lnSpc>
-                        <a:buNone/>
-                        <a:defRPr sz="2000" b="0">
-                          <a:solidFill>
-                            <a:srgbClr val="303437"/>
-                          </a:solidFill>
-                          <a:latin typeface="Noto Sans"/>
-                        </a:defRPr>
-                      </a:pPr>
-                      <a:r>
-                        <a:rPr sz="2000" b="0" lang="ja-JP" altLang="en-US">
-                          <a:solidFill>
-                            <a:srgbClr val="303437"/>
-                          </a:solidFill>
-                          <a:latin typeface="Noto Sans"/>
-                          <a:ea typeface="Noto Sans CJK JP"/>
-                          <a:cs typeface="Noto Sans"/>
-                        </a:rPr>
-                        <a:t>6</a:t>
-                      </a:r>
-                    </a:p>
-                  </a:txBody>
-                  <a:tcPr marL="63500" marR="63500" marT="38100" marB="38100" anchor="ctr">
-                    <a:lnL w="7620">
-                      <a:noFill/>
-                    </a:lnL>
-                    <a:lnR w="7620">
-                      <a:noFill/>
-                    </a:lnR>
-                    <a:lnT w="7620">
-                      <a:noFill/>
-                    </a:lnT>
-                    <a:lnB w="15240">
-                      <a:solidFill>
-                        <a:srgbClr val="626669"/>
-                      </a:solidFill>
-                      <a:prstDash val="solid"/>
-                    </a:lnB>
-                    <a:solidFill>
-                      <a:srgbClr val="FFFEF8"/>
-                    </a:solidFill>
-                  </a:tcPr>
-                </a:tc>
-              </a:tr>
-            </a:tbl>
-          </a:graphicData>
-        </a:graphic>
-      </p:graphicFrame>
-      <p:sp>
-        <p:nvSpPr>
-          <p:cNvPr id="5" name="TextBox 4"/>
-          <p:cNvSpPr txBox="1"/>
-          <p:nvPr/>
-        </p:nvSpPr>
-        <p:spPr>
-          <a:xfrm>
-            <a:off x="502920" y="4690872"/>
-            <a:ext cx="8183879" cy="393192"/>
-          </a:xfrm>
-          <a:prstGeom prst="rect">
-            <a:avLst/>
-          </a:prstGeom>
-          <a:noFill/>
-        </p:spPr>
-        <p:txBody>
-          <a:bodyPr wrap="square" lIns="0" rIns="0" tIns="0" bIns="0">
-            <a:noAutofit/>
-          </a:bodyPr>
-          <a:lstStyle/>
-          <a:p>
-            <a:pPr algn="l">
-              <a:lnSpc>
-                <a:spcPct val="112000"/>
-              </a:lnSpc>
-              <a:spcBef>
-                <a:spcPts val="0"/>
-              </a:spcBef>
-              <a:spcAft>
-                <a:spcPts val="0"/>
-              </a:spcAft>
-              <a:buNone/>
-              <a:defRPr sz="810" b="0">
-                <a:solidFill>
-                  <a:srgbClr val="303437"/>
-                </a:solidFill>
-                <a:latin typeface="Noto Sans"/>
-              </a:defRPr>
-            </a:pPr>
-            <a:r>
-              <a:rPr sz="810" b="0" lang="ja-JP" altLang="en-US">
-                <a:solidFill>
-                  <a:srgbClr val="626669"/>
-                </a:solidFill>
-                <a:latin typeface="Noto Sans"/>
-                <a:ea typeface="Noto Sans CJK JP"/>
-                <a:cs typeface="Noto Sans"/>
-              </a:rPr>
-              <a:t/>
-            </a:r>
-            <a:r>
-              <a:rPr sz="810" b="0" lang="ja-JP" altLang="en-US">
-                <a:solidFill>
-                  <a:srgbClr val="626669"/>
-                </a:solidFill>
-                <a:latin typeface="Noto Sans"/>
-                <a:ea typeface="Noto Sans CJK JP"/>
-                <a:cs typeface="Noto Sans"/>
-              </a:rPr>
-              <a:t>Sierra (2025). τ²-bench. 公開版v0.2.0、278課題。2026-10-16集計。</a:t>
-            </a:r>
-            <a:r>
-              <a:rPr sz="810" b="0" lang="ja-JP" altLang="en-US">
-                <a:solidFill>
-                  <a:srgbClr val="626669"/>
-                </a:solidFill>
-                <a:latin typeface="Noto Sans"/>
-                <a:ea typeface="Noto Sans CJK JP"/>
-                <a:cs typeface="Noto Sans"/>
-              </a:rPr>
-              <a:t>  </a:t>
-            </a:r>
-            <a:r>
-              <a:rPr sz="810" b="0" lang="ja-JP" altLang="en-US">
-                <a:solidFill>
-                  <a:srgbClr val="626669"/>
-                </a:solidFill>
-                <a:latin typeface="Noto Sans"/>
-                <a:ea typeface="Noto Sans CJK JP"/>
-                <a:cs typeface="Noto Sans"/>
-                <a:hlinkClick r:id="rId2"/>
-              </a:rPr>
-              <a:t>https://github.com/sierra-research/tau2-bench/tree/v0.2.0/data/tau2/domains</a:t>
-            </a:r>
-          </a:p>
-        </p:txBody>
-      </p:sp>
-    </p:spTree>
-  </p:cSld>
-  <p:clrMapOvr>
-    <a:masterClrMapping/>
-  </p:clrMapOvr>
-</p:sld>
-</file>
-
-<file path=ppt/slides/slide56.xml><?xml version="1.0" encoding="utf-8"?>
-<p:sld xmlns:a="http://schemas.openxmlformats.org/drawingml/2006/main" xmlns:p="http://schemas.openxmlformats.org/presentationml/2006/main" xmlns:r="http://schemas.openxmlformats.org/officeDocument/2006/relationships">
-  <p:cSld>
-    <p:spTree>
-      <p:nvGrpSpPr>
-        <p:cNvPr id="1" name=""/>
-        <p:cNvGrpSpPr/>
-        <p:nvPr/>
-      </p:nvGrpSpPr>
-      <p:grpSpPr/>
-      <p:sp>
-        <p:nvSpPr>
-          <p:cNvPr id="2" name="Title 1"/>
-          <p:cNvSpPr>
-            <a:spLocks noGrp="1"/>
-          </p:cNvSpPr>
-          <p:nvPr>
-            <p:ph type="title"/>
-          </p:nvPr>
-        </p:nvSpPr>
-        <p:spPr>
-          <a:xfrm>
-            <a:off x="548640" y="786384"/>
-            <a:ext cx="8046720" cy="502920"/>
-          </a:xfrm>
-        </p:spPr>
-        <p:txBody>
-          <a:bodyPr wrap="square" lIns="0" rIns="0" tIns="0" bIns="0">
-            <a:noAutofit/>
-          </a:bodyPr>
-          <a:lstStyle/>
-          <a:p>
-            <a:pPr algn="l">
-              <a:lnSpc>
-                <a:spcPct val="110000"/>
-              </a:lnSpc>
-              <a:buNone/>
-              <a:defRPr sz="2800" b="0">
-                <a:solidFill>
-                  <a:srgbClr val="303437"/>
-                </a:solidFill>
-                <a:latin typeface="Noto Sans"/>
-              </a:defRPr>
-            </a:pPr>
-            <a:r>
-              <a:rPr sz="2800" b="1" lang="ja-JP" altLang="en-US">
-                <a:solidFill>
-                  <a:srgbClr val="303437"/>
-                </a:solidFill>
-                <a:latin typeface="Noto Sans"/>
-                <a:ea typeface="Noto Sans CJK JP"/>
-                <a:cs typeface="Noto Sans"/>
-              </a:rPr>
-              <a:t>公開版の読取・更新ツールの数</a:t>
-            </a:r>
-          </a:p>
-        </p:txBody>
-      </p:sp>
-      <p:sp>
-        <p:nvSpPr>
-          <p:cNvPr id="3" name="Title 2"/>
-          <p:cNvSpPr>
-            <a:spLocks noGrp="1"/>
-          </p:cNvSpPr>
-          <p:nvPr>
-            <p:ph type="title" idx="2"/>
-          </p:nvPr>
-        </p:nvSpPr>
-        <p:spPr>
-          <a:xfrm>
-            <a:off x="75895" y="0"/>
-            <a:ext cx="8115300" cy="480060"/>
-          </a:xfrm>
-        </p:spPr>
-        <p:txBody>
-          <a:bodyPr wrap="square" lIns="0" rIns="0" tIns="0" bIns="0" anchor="ctr">
-            <a:noAutofit/>
-          </a:bodyPr>
-          <a:lstStyle/>
-          <a:p>
-            <a:pPr algn="l">
-              <a:lnSpc>
-                <a:spcPct val="110000"/>
-              </a:lnSpc>
-              <a:buNone/>
-              <a:defRPr sz="1400" b="0">
-                <a:solidFill>
-                  <a:srgbClr val="303437"/>
-                </a:solidFill>
-                <a:latin typeface="Noto Sans"/>
-              </a:defRPr>
-            </a:pPr>
-            <a:r>
-              <a:rPr sz="1400" b="1" lang="ja-JP" altLang="en-US">
-                <a:solidFill>
-                  <a:srgbClr val="FFFFFF"/>
-                </a:solidFill>
-                <a:latin typeface="Noto Sans"/>
-                <a:ea typeface="Noto Sans CJK JP"/>
-                <a:cs typeface="Noto Sans"/>
-              </a:rPr>
-              <a:t>Appendix: 2. 指標・版・公開データ</a:t>
-            </a:r>
-          </a:p>
-        </p:txBody>
-      </p:sp>
-      <p:graphicFrame>
-        <p:nvGraphicFramePr>
-          <p:cNvPr id="4" name="Table 3"/>
-          <p:cNvGraphicFramePr>
-            <a:graphicFrameLocks noGrp="1"/>
-          </p:cNvGraphicFramePr>
-          <p:nvPr/>
-        </p:nvGraphicFramePr>
-        <p:xfrm>
-          <a:off x="548640" y="1508760"/>
-          <a:ext cx="8046720" cy="2532888"/>
-        </p:xfrm>
-        <a:graphic>
-          <a:graphicData uri="http://schemas.openxmlformats.org/drawingml/2006/table">
-            <a:tbl>
-              <a:tblPr firstRow="0" bandRow="0"/>
-              <a:tblGrid>
-                <a:gridCol w="1463040"/>
-                <a:gridCol w="3291840"/>
+                <a:gridCol w="4754880"/>
                 <a:gridCol w="3291840"/>
               </a:tblGrid>
               <a:tr h="475488">
@@ -29401,7 +27880,7 @@
                           <a:ea typeface="Noto Sans CJK JP"/>
                           <a:cs typeface="Noto Sans"/>
                         </a:rPr>
-                        <a:t>領域</a:t>
+                        <a:t>1課題に含む不具合の数</a:t>
                       </a:r>
                     </a:p>
                   </a:txBody>
@@ -29457,7 +27936,796 @@
                           <a:ea typeface="Noto Sans CJK JP"/>
                           <a:cs typeface="Noto Sans"/>
                         </a:rPr>
-                        <a:t>担当者：読取／更新</a:t>
+                        <a:t>該当する課題の件数</a:t>
+                      </a:r>
+                    </a:p>
+                  </a:txBody>
+                  <a:tcPr marL="63500" marR="63500" marT="38100" marB="38100" anchor="ctr">
+                    <a:lnL w="7620">
+                      <a:noFill/>
+                    </a:lnL>
+                    <a:lnR w="7620">
+                      <a:noFill/>
+                    </a:lnR>
+                    <a:lnT w="15240">
+                      <a:solidFill>
+                        <a:srgbClr val="626669"/>
+                      </a:solidFill>
+                      <a:prstDash val="solid"/>
+                    </a:lnT>
+                    <a:lnB w="7620">
+                      <a:solidFill>
+                        <a:srgbClr val="626669"/>
+                      </a:solidFill>
+                      <a:prstDash val="solid"/>
+                    </a:lnB>
+                    <a:solidFill>
+                      <a:srgbClr val="FFFEF8"/>
+                    </a:solidFill>
+                  </a:tcPr>
+                </a:tc>
+              </a:tr>
+              <a:tr h="457200">
+                <a:tc>
+                  <a:txBody>
+                    <a:bodyPr wrap="square">
+                      <a:noAutofit/>
+                    </a:bodyPr>
+                    <a:lstStyle/>
+                    <a:p>
+                      <a:pPr algn="l">
+                        <a:lnSpc>
+                          <a:spcPts val="2300"/>
+                        </a:lnSpc>
+                        <a:buNone/>
+                        <a:defRPr sz="2000" b="0">
+                          <a:solidFill>
+                            <a:srgbClr val="303437"/>
+                          </a:solidFill>
+                          <a:latin typeface="Noto Sans"/>
+                        </a:defRPr>
+                      </a:pPr>
+                      <a:r>
+                        <a:rPr sz="2000" b="0" lang="ja-JP" altLang="en-US">
+                          <a:solidFill>
+                            <a:srgbClr val="303437"/>
+                          </a:solidFill>
+                          <a:latin typeface="Noto Sans"/>
+                          <a:ea typeface="Noto Sans CJK JP"/>
+                          <a:cs typeface="Noto Sans"/>
+                        </a:rPr>
+                        <a:t>2個</a:t>
+                      </a:r>
+                    </a:p>
+                  </a:txBody>
+                  <a:tcPr marL="63500" marR="63500" marT="38100" marB="38100" anchor="ctr">
+                    <a:lnL w="7620">
+                      <a:noFill/>
+                    </a:lnL>
+                    <a:lnR w="7620">
+                      <a:noFill/>
+                    </a:lnR>
+                    <a:lnT w="7620">
+                      <a:solidFill>
+                        <a:srgbClr val="626669"/>
+                      </a:solidFill>
+                      <a:prstDash val="solid"/>
+                    </a:lnT>
+                    <a:lnB w="7620">
+                      <a:noFill/>
+                    </a:lnB>
+                    <a:solidFill>
+                      <a:srgbClr val="FFFEF8"/>
+                    </a:solidFill>
+                  </a:tcPr>
+                </a:tc>
+                <a:tc>
+                  <a:txBody>
+                    <a:bodyPr wrap="square">
+                      <a:noAutofit/>
+                    </a:bodyPr>
+                    <a:lstStyle/>
+                    <a:p>
+                      <a:pPr algn="l">
+                        <a:lnSpc>
+                          <a:spcPts val="2300"/>
+                        </a:lnSpc>
+                        <a:buNone/>
+                        <a:defRPr sz="2000" b="0">
+                          <a:solidFill>
+                            <a:srgbClr val="303437"/>
+                          </a:solidFill>
+                          <a:latin typeface="Noto Sans"/>
+                        </a:defRPr>
+                      </a:pPr>
+                      <a:r>
+                        <a:rPr sz="2000" b="0" lang="ja-JP" altLang="en-US">
+                          <a:solidFill>
+                            <a:srgbClr val="303437"/>
+                          </a:solidFill>
+                          <a:latin typeface="Noto Sans"/>
+                          <a:ea typeface="Noto Sans CJK JP"/>
+                          <a:cs typeface="Noto Sans"/>
+                        </a:rPr>
+                        <a:t>25件</a:t>
+                      </a:r>
+                    </a:p>
+                  </a:txBody>
+                  <a:tcPr marL="63500" marR="63500" marT="38100" marB="38100" anchor="ctr">
+                    <a:lnL w="7620">
+                      <a:noFill/>
+                    </a:lnL>
+                    <a:lnR w="7620">
+                      <a:noFill/>
+                    </a:lnR>
+                    <a:lnT w="7620">
+                      <a:solidFill>
+                        <a:srgbClr val="626669"/>
+                      </a:solidFill>
+                      <a:prstDash val="solid"/>
+                    </a:lnT>
+                    <a:lnB w="7620">
+                      <a:noFill/>
+                    </a:lnB>
+                    <a:solidFill>
+                      <a:srgbClr val="FFFEF8"/>
+                    </a:solidFill>
+                  </a:tcPr>
+                </a:tc>
+              </a:tr>
+              <a:tr h="457200">
+                <a:tc>
+                  <a:txBody>
+                    <a:bodyPr wrap="square">
+                      <a:noAutofit/>
+                    </a:bodyPr>
+                    <a:lstStyle/>
+                    <a:p>
+                      <a:pPr algn="l">
+                        <a:lnSpc>
+                          <a:spcPts val="2300"/>
+                        </a:lnSpc>
+                        <a:buNone/>
+                        <a:defRPr sz="2000" b="0">
+                          <a:solidFill>
+                            <a:srgbClr val="303437"/>
+                          </a:solidFill>
+                          <a:latin typeface="Noto Sans"/>
+                        </a:defRPr>
+                      </a:pPr>
+                      <a:r>
+                        <a:rPr sz="2000" b="0" lang="ja-JP" altLang="en-US">
+                          <a:solidFill>
+                            <a:srgbClr val="303437"/>
+                          </a:solidFill>
+                          <a:latin typeface="Noto Sans"/>
+                          <a:ea typeface="Noto Sans CJK JP"/>
+                          <a:cs typeface="Noto Sans"/>
+                        </a:rPr>
+                        <a:t>3個</a:t>
+                      </a:r>
+                    </a:p>
+                  </a:txBody>
+                  <a:tcPr marL="63500" marR="63500" marT="38100" marB="38100" anchor="ctr">
+                    <a:lnL w="7620">
+                      <a:noFill/>
+                    </a:lnL>
+                    <a:lnR w="7620">
+                      <a:noFill/>
+                    </a:lnR>
+                    <a:lnT w="7620">
+                      <a:noFill/>
+                    </a:lnT>
+                    <a:lnB w="7620">
+                      <a:noFill/>
+                    </a:lnB>
+                    <a:solidFill>
+                      <a:srgbClr val="FFFEF8"/>
+                    </a:solidFill>
+                  </a:tcPr>
+                </a:tc>
+                <a:tc>
+                  <a:txBody>
+                    <a:bodyPr wrap="square">
+                      <a:noAutofit/>
+                    </a:bodyPr>
+                    <a:lstStyle/>
+                    <a:p>
+                      <a:pPr algn="l">
+                        <a:lnSpc>
+                          <a:spcPts val="2300"/>
+                        </a:lnSpc>
+                        <a:buNone/>
+                        <a:defRPr sz="2000" b="0">
+                          <a:solidFill>
+                            <a:srgbClr val="303437"/>
+                          </a:solidFill>
+                          <a:latin typeface="Noto Sans"/>
+                        </a:defRPr>
+                      </a:pPr>
+                      <a:r>
+                        <a:rPr sz="2000" b="0" lang="ja-JP" altLang="en-US">
+                          <a:solidFill>
+                            <a:srgbClr val="303437"/>
+                          </a:solidFill>
+                          <a:latin typeface="Noto Sans"/>
+                          <a:ea typeface="Noto Sans CJK JP"/>
+                          <a:cs typeface="Noto Sans"/>
+                        </a:rPr>
+                        <a:t>26件</a:t>
+                      </a:r>
+                    </a:p>
+                  </a:txBody>
+                  <a:tcPr marL="63500" marR="63500" marT="38100" marB="38100" anchor="ctr">
+                    <a:lnL w="7620">
+                      <a:noFill/>
+                    </a:lnL>
+                    <a:lnR w="7620">
+                      <a:noFill/>
+                    </a:lnR>
+                    <a:lnT w="7620">
+                      <a:noFill/>
+                    </a:lnT>
+                    <a:lnB w="7620">
+                      <a:noFill/>
+                    </a:lnB>
+                    <a:solidFill>
+                      <a:srgbClr val="FFFEF8"/>
+                    </a:solidFill>
+                  </a:tcPr>
+                </a:tc>
+              </a:tr>
+              <a:tr h="457200">
+                <a:tc>
+                  <a:txBody>
+                    <a:bodyPr wrap="square">
+                      <a:noAutofit/>
+                    </a:bodyPr>
+                    <a:lstStyle/>
+                    <a:p>
+                      <a:pPr algn="l">
+                        <a:lnSpc>
+                          <a:spcPts val="2300"/>
+                        </a:lnSpc>
+                        <a:buNone/>
+                        <a:defRPr sz="2000" b="0">
+                          <a:solidFill>
+                            <a:srgbClr val="303437"/>
+                          </a:solidFill>
+                          <a:latin typeface="Noto Sans"/>
+                        </a:defRPr>
+                      </a:pPr>
+                      <a:r>
+                        <a:rPr sz="2000" b="0" lang="ja-JP" altLang="en-US">
+                          <a:solidFill>
+                            <a:srgbClr val="303437"/>
+                          </a:solidFill>
+                          <a:latin typeface="Noto Sans"/>
+                          <a:ea typeface="Noto Sans CJK JP"/>
+                          <a:cs typeface="Noto Sans"/>
+                        </a:rPr>
+                        <a:t>4個</a:t>
+                      </a:r>
+                    </a:p>
+                  </a:txBody>
+                  <a:tcPr marL="63500" marR="63500" marT="38100" marB="38100" anchor="ctr">
+                    <a:lnL w="7620">
+                      <a:noFill/>
+                    </a:lnL>
+                    <a:lnR w="7620">
+                      <a:noFill/>
+                    </a:lnR>
+                    <a:lnT w="7620">
+                      <a:noFill/>
+                    </a:lnT>
+                    <a:lnB w="7620">
+                      <a:noFill/>
+                    </a:lnB>
+                    <a:solidFill>
+                      <a:srgbClr val="FFFEF8"/>
+                    </a:solidFill>
+                  </a:tcPr>
+                </a:tc>
+                <a:tc>
+                  <a:txBody>
+                    <a:bodyPr wrap="square">
+                      <a:noAutofit/>
+                    </a:bodyPr>
+                    <a:lstStyle/>
+                    <a:p>
+                      <a:pPr algn="l">
+                        <a:lnSpc>
+                          <a:spcPts val="2300"/>
+                        </a:lnSpc>
+                        <a:buNone/>
+                        <a:defRPr sz="2000" b="0">
+                          <a:solidFill>
+                            <a:srgbClr val="303437"/>
+                          </a:solidFill>
+                          <a:latin typeface="Noto Sans"/>
+                        </a:defRPr>
+                      </a:pPr>
+                      <a:r>
+                        <a:rPr sz="2000" b="0" lang="ja-JP" altLang="en-US">
+                          <a:solidFill>
+                            <a:srgbClr val="303437"/>
+                          </a:solidFill>
+                          <a:latin typeface="Noto Sans"/>
+                          <a:ea typeface="Noto Sans CJK JP"/>
+                          <a:cs typeface="Noto Sans"/>
+                        </a:rPr>
+                        <a:t>21件</a:t>
+                      </a:r>
+                    </a:p>
+                  </a:txBody>
+                  <a:tcPr marL="63500" marR="63500" marT="38100" marB="38100" anchor="ctr">
+                    <a:lnL w="7620">
+                      <a:noFill/>
+                    </a:lnL>
+                    <a:lnR w="7620">
+                      <a:noFill/>
+                    </a:lnR>
+                    <a:lnT w="7620">
+                      <a:noFill/>
+                    </a:lnT>
+                    <a:lnB w="7620">
+                      <a:noFill/>
+                    </a:lnB>
+                    <a:solidFill>
+                      <a:srgbClr val="FFFEF8"/>
+                    </a:solidFill>
+                  </a:tcPr>
+                </a:tc>
+              </a:tr>
+              <a:tr h="457200">
+                <a:tc>
+                  <a:txBody>
+                    <a:bodyPr wrap="square">
+                      <a:noAutofit/>
+                    </a:bodyPr>
+                    <a:lstStyle/>
+                    <a:p>
+                      <a:pPr algn="l">
+                        <a:lnSpc>
+                          <a:spcPts val="2300"/>
+                        </a:lnSpc>
+                        <a:buNone/>
+                        <a:defRPr sz="2000" b="0">
+                          <a:solidFill>
+                            <a:srgbClr val="303437"/>
+                          </a:solidFill>
+                          <a:latin typeface="Noto Sans"/>
+                        </a:defRPr>
+                      </a:pPr>
+                      <a:r>
+                        <a:rPr sz="2000" b="0" lang="ja-JP" altLang="en-US">
+                          <a:solidFill>
+                            <a:srgbClr val="303437"/>
+                          </a:solidFill>
+                          <a:latin typeface="Noto Sans"/>
+                          <a:ea typeface="Noto Sans CJK JP"/>
+                          <a:cs typeface="Noto Sans"/>
+                        </a:rPr>
+                        <a:t>5個</a:t>
+                      </a:r>
+                    </a:p>
+                  </a:txBody>
+                  <a:tcPr marL="63500" marR="63500" marT="38100" marB="38100" anchor="ctr">
+                    <a:lnL w="7620">
+                      <a:noFill/>
+                    </a:lnL>
+                    <a:lnR w="7620">
+                      <a:noFill/>
+                    </a:lnR>
+                    <a:lnT w="7620">
+                      <a:noFill/>
+                    </a:lnT>
+                    <a:lnB w="15240">
+                      <a:solidFill>
+                        <a:srgbClr val="626669"/>
+                      </a:solidFill>
+                      <a:prstDash val="solid"/>
+                    </a:lnB>
+                    <a:solidFill>
+                      <a:srgbClr val="FFFEF8"/>
+                    </a:solidFill>
+                  </a:tcPr>
+                </a:tc>
+                <a:tc>
+                  <a:txBody>
+                    <a:bodyPr wrap="square">
+                      <a:noAutofit/>
+                    </a:bodyPr>
+                    <a:lstStyle/>
+                    <a:p>
+                      <a:pPr algn="l">
+                        <a:lnSpc>
+                          <a:spcPts val="2300"/>
+                        </a:lnSpc>
+                        <a:buNone/>
+                        <a:defRPr sz="2000" b="0">
+                          <a:solidFill>
+                            <a:srgbClr val="303437"/>
+                          </a:solidFill>
+                          <a:latin typeface="Noto Sans"/>
+                        </a:defRPr>
+                      </a:pPr>
+                      <a:r>
+                        <a:rPr sz="2000" b="0" lang="ja-JP" altLang="en-US">
+                          <a:solidFill>
+                            <a:srgbClr val="303437"/>
+                          </a:solidFill>
+                          <a:latin typeface="Noto Sans"/>
+                          <a:ea typeface="Noto Sans CJK JP"/>
+                          <a:cs typeface="Noto Sans"/>
+                        </a:rPr>
+                        <a:t>13件</a:t>
+                      </a:r>
+                    </a:p>
+                  </a:txBody>
+                  <a:tcPr marL="63500" marR="63500" marT="38100" marB="38100" anchor="ctr">
+                    <a:lnL w="7620">
+                      <a:noFill/>
+                    </a:lnL>
+                    <a:lnR w="7620">
+                      <a:noFill/>
+                    </a:lnR>
+                    <a:lnT w="7620">
+                      <a:noFill/>
+                    </a:lnT>
+                    <a:lnB w="15240">
+                      <a:solidFill>
+                        <a:srgbClr val="626669"/>
+                      </a:solidFill>
+                      <a:prstDash val="solid"/>
+                    </a:lnB>
+                    <a:solidFill>
+                      <a:srgbClr val="FFFEF8"/>
+                    </a:solidFill>
+                  </a:tcPr>
+                </a:tc>
+              </a:tr>
+            </a:tbl>
+          </a:graphicData>
+        </a:graphic>
+      </p:graphicFrame>
+      <p:sp>
+        <p:nvSpPr>
+          <p:cNvPr id="5" name="TextBox 4"/>
+          <p:cNvSpPr txBox="1"/>
+          <p:nvPr/>
+        </p:nvSpPr>
+        <p:spPr>
+          <a:xfrm>
+            <a:off x="594360" y="4005072"/>
+            <a:ext cx="7955279" cy="685800"/>
+          </a:xfrm>
+          <a:prstGeom prst="rect">
+            <a:avLst/>
+          </a:prstGeom>
+          <a:noFill/>
+        </p:spPr>
+        <p:txBody>
+          <a:bodyPr wrap="square" lIns="0" rIns="0" tIns="0" bIns="0">
+            <a:noAutofit/>
+          </a:bodyPr>
+          <a:lstStyle/>
+          <a:p>
+            <a:pPr algn="l">
+              <a:lnSpc>
+                <a:spcPts val="2160"/>
+              </a:lnSpc>
+              <a:spcBef>
+                <a:spcPts val="0"/>
+              </a:spcBef>
+              <a:spcAft>
+                <a:spcPts val="0"/>
+              </a:spcAft>
+              <a:buNone/>
+              <a:defRPr sz="1800" b="0">
+                <a:solidFill>
+                  <a:srgbClr val="303437"/>
+                </a:solidFill>
+                <a:latin typeface="Noto Sans"/>
+              </a:defRPr>
+            </a:pPr>
+            <a:r>
+              <a:rPr sz="1800" b="0" lang="ja-JP" altLang="en-US">
+                <a:solidFill>
+                  <a:srgbClr val="303437"/>
+                </a:solidFill>
+                <a:latin typeface="Noto Sans"/>
+                <a:ea typeface="Noto Sans CJK JP"/>
+                <a:cs typeface="Noto Sans"/>
+              </a:rPr>
+              <a:t>例：通信OFF＋データ容量超過 → 不具合2個。</a:t>
+            </a:r>
+          </a:p>
+          <a:p>
+            <a:pPr algn="l">
+              <a:lnSpc>
+                <a:spcPts val="2160"/>
+              </a:lnSpc>
+              <a:spcBef>
+                <a:spcPts val="0"/>
+              </a:spcBef>
+              <a:spcAft>
+                <a:spcPts val="0"/>
+              </a:spcAft>
+              <a:buNone/>
+              <a:defRPr sz="1800" b="0">
+                <a:solidFill>
+                  <a:srgbClr val="303437"/>
+                </a:solidFill>
+                <a:latin typeface="Noto Sans"/>
+              </a:defRPr>
+            </a:pPr>
+            <a:r>
+              <a:rPr sz="1800" b="0" lang="ja-JP" altLang="en-US">
+                <a:solidFill>
+                  <a:srgbClr val="303437"/>
+                </a:solidFill>
+                <a:latin typeface="Noto Sans"/>
+                <a:ea typeface="Noto Sans CJK JP"/>
+                <a:cs typeface="Noto Sans"/>
+              </a:rPr>
+              <a:t>不具合2個の課題は25件。対象は通信課題114件。</a:t>
+            </a:r>
+          </a:p>
+        </p:txBody>
+      </p:sp>
+      <p:sp>
+        <p:nvSpPr>
+          <p:cNvPr id="6" name="TextBox 5"/>
+          <p:cNvSpPr txBox="1"/>
+          <p:nvPr/>
+        </p:nvSpPr>
+        <p:spPr>
+          <a:xfrm>
+            <a:off x="502920" y="4690872"/>
+            <a:ext cx="8183879" cy="393192"/>
+          </a:xfrm>
+          <a:prstGeom prst="rect">
+            <a:avLst/>
+          </a:prstGeom>
+          <a:noFill/>
+        </p:spPr>
+        <p:txBody>
+          <a:bodyPr wrap="square" lIns="0" rIns="0" tIns="0" bIns="0">
+            <a:noAutofit/>
+          </a:bodyPr>
+          <a:lstStyle/>
+          <a:p>
+            <a:pPr algn="l">
+              <a:lnSpc>
+                <a:spcPct val="112000"/>
+              </a:lnSpc>
+              <a:spcBef>
+                <a:spcPts val="0"/>
+              </a:spcBef>
+              <a:spcAft>
+                <a:spcPts val="0"/>
+              </a:spcAft>
+              <a:buNone/>
+              <a:defRPr sz="810" b="0">
+                <a:solidFill>
+                  <a:srgbClr val="303437"/>
+                </a:solidFill>
+                <a:latin typeface="Noto Sans"/>
+              </a:defRPr>
+            </a:pPr>
+            <a:r>
+              <a:rPr sz="810" b="0" lang="ja-JP" altLang="en-US">
+                <a:solidFill>
+                  <a:srgbClr val="626669"/>
+                </a:solidFill>
+                <a:latin typeface="Noto Sans"/>
+                <a:ea typeface="Noto Sans CJK JP"/>
+                <a:cs typeface="Noto Sans"/>
+              </a:rPr>
+              <a:t/>
+            </a:r>
+            <a:r>
+              <a:rPr sz="810" b="0" lang="ja-JP" altLang="en-US">
+                <a:solidFill>
+                  <a:srgbClr val="626669"/>
+                </a:solidFill>
+                <a:latin typeface="Noto Sans"/>
+                <a:ea typeface="Noto Sans CJK JP"/>
+                <a:cs typeface="Noto Sans"/>
+              </a:rPr>
+              <a:t>Sierra (2025). τ²-bench. 公開版v0.2.0、278課題。2026-10-16集計。</a:t>
+            </a:r>
+            <a:r>
+              <a:rPr sz="810" b="0" lang="ja-JP" altLang="en-US">
+                <a:solidFill>
+                  <a:srgbClr val="626669"/>
+                </a:solidFill>
+                <a:latin typeface="Noto Sans"/>
+                <a:ea typeface="Noto Sans CJK JP"/>
+                <a:cs typeface="Noto Sans"/>
+              </a:rPr>
+              <a:t>  </a:t>
+            </a:r>
+            <a:r>
+              <a:rPr sz="810" b="0" lang="ja-JP" altLang="en-US">
+                <a:solidFill>
+                  <a:srgbClr val="626669"/>
+                </a:solidFill>
+                <a:latin typeface="Noto Sans"/>
+                <a:ea typeface="Noto Sans CJK JP"/>
+                <a:cs typeface="Noto Sans"/>
+                <a:hlinkClick r:id="rId2"/>
+              </a:rPr>
+              <a:t>https://github.com/sierra-research/tau2-bench/tree/v0.2.0/data/tau2/domains</a:t>
+            </a:r>
+          </a:p>
+        </p:txBody>
+      </p:sp>
+    </p:spTree>
+  </p:cSld>
+  <p:clrMapOvr>
+    <a:masterClrMapping/>
+  </p:clrMapOvr>
+</p:sld>
+</file>
+
+<file path=ppt/slides/slide55.xml><?xml version="1.0" encoding="utf-8"?>
+<p:sld xmlns:a="http://schemas.openxmlformats.org/drawingml/2006/main" xmlns:p="http://schemas.openxmlformats.org/presentationml/2006/main" xmlns:r="http://schemas.openxmlformats.org/officeDocument/2006/relationships">
+  <p:cSld>
+    <p:spTree>
+      <p:nvGrpSpPr>
+        <p:cNvPr id="1" name=""/>
+        <p:cNvGrpSpPr/>
+        <p:nvPr/>
+      </p:nvGrpSpPr>
+      <p:grpSpPr/>
+      <p:sp>
+        <p:nvSpPr>
+          <p:cNvPr id="2" name="Title 1"/>
+          <p:cNvSpPr>
+            <a:spLocks noGrp="1"/>
+          </p:cNvSpPr>
+          <p:nvPr>
+            <p:ph type="title"/>
+          </p:nvPr>
+        </p:nvSpPr>
+        <p:spPr>
+          <a:xfrm>
+            <a:off x="548640" y="786384"/>
+            <a:ext cx="8046720" cy="502920"/>
+          </a:xfrm>
+        </p:spPr>
+        <p:txBody>
+          <a:bodyPr wrap="square" lIns="0" rIns="0" tIns="0" bIns="0">
+            <a:noAutofit/>
+          </a:bodyPr>
+          <a:lstStyle/>
+          <a:p>
+            <a:pPr algn="l">
+              <a:lnSpc>
+                <a:spcPct val="110000"/>
+              </a:lnSpc>
+              <a:buNone/>
+              <a:defRPr sz="2800" b="0">
+                <a:solidFill>
+                  <a:srgbClr val="303437"/>
+                </a:solidFill>
+                <a:latin typeface="Noto Sans"/>
+              </a:defRPr>
+            </a:pPr>
+            <a:r>
+              <a:rPr sz="2800" b="1" lang="ja-JP" altLang="en-US">
+                <a:solidFill>
+                  <a:srgbClr val="303437"/>
+                </a:solidFill>
+                <a:latin typeface="Noto Sans"/>
+                <a:ea typeface="Noto Sans CJK JP"/>
+                <a:cs typeface="Noto Sans"/>
+              </a:rPr>
+              <a:t>1課題に組み合わせた不具合の数（6〜9個）</a:t>
+            </a:r>
+          </a:p>
+        </p:txBody>
+      </p:sp>
+      <p:sp>
+        <p:nvSpPr>
+          <p:cNvPr id="3" name="Title 2"/>
+          <p:cNvSpPr>
+            <a:spLocks noGrp="1"/>
+          </p:cNvSpPr>
+          <p:nvPr>
+            <p:ph type="title" idx="2"/>
+          </p:nvPr>
+        </p:nvSpPr>
+        <p:spPr>
+          <a:xfrm>
+            <a:off x="75895" y="0"/>
+            <a:ext cx="8115300" cy="480060"/>
+          </a:xfrm>
+        </p:spPr>
+        <p:txBody>
+          <a:bodyPr wrap="square" lIns="0" rIns="0" tIns="0" bIns="0" anchor="ctr">
+            <a:noAutofit/>
+          </a:bodyPr>
+          <a:lstStyle/>
+          <a:p>
+            <a:pPr algn="l">
+              <a:lnSpc>
+                <a:spcPct val="110000"/>
+              </a:lnSpc>
+              <a:buNone/>
+              <a:defRPr sz="1400" b="0">
+                <a:solidFill>
+                  <a:srgbClr val="303437"/>
+                </a:solidFill>
+                <a:latin typeface="Noto Sans"/>
+              </a:defRPr>
+            </a:pPr>
+            <a:r>
+              <a:rPr sz="1400" b="1" lang="ja-JP" altLang="en-US">
+                <a:solidFill>
+                  <a:srgbClr val="FFFFFF"/>
+                </a:solidFill>
+                <a:latin typeface="Noto Sans"/>
+                <a:ea typeface="Noto Sans CJK JP"/>
+                <a:cs typeface="Noto Sans"/>
+              </a:rPr>
+              <a:t>Appendix: 2. 指標・版・公開データ</a:t>
+            </a:r>
+          </a:p>
+        </p:txBody>
+      </p:sp>
+      <p:graphicFrame>
+        <p:nvGraphicFramePr>
+          <p:cNvPr id="4" name="Table 3"/>
+          <p:cNvGraphicFramePr>
+            <a:graphicFrameLocks noGrp="1"/>
+          </p:cNvGraphicFramePr>
+          <p:nvPr/>
+        </p:nvGraphicFramePr>
+        <p:xfrm>
+          <a:off x="548640" y="1508760"/>
+          <a:ext cx="8046720" cy="2304288"/>
+        </p:xfrm>
+        <a:graphic>
+          <a:graphicData uri="http://schemas.openxmlformats.org/drawingml/2006/table">
+            <a:tbl>
+              <a:tblPr firstRow="0" bandRow="0"/>
+              <a:tblGrid>
+                <a:gridCol w="4754880"/>
+                <a:gridCol w="3291840"/>
+              </a:tblGrid>
+              <a:tr h="475488">
+                <a:tc>
+                  <a:txBody>
+                    <a:bodyPr wrap="square">
+                      <a:noAutofit/>
+                    </a:bodyPr>
+                    <a:lstStyle/>
+                    <a:p>
+                      <a:pPr algn="l">
+                        <a:lnSpc>
+                          <a:spcPts val="2300"/>
+                        </a:lnSpc>
+                        <a:buNone/>
+                        <a:defRPr sz="2000" b="0">
+                          <a:solidFill>
+                            <a:srgbClr val="303437"/>
+                          </a:solidFill>
+                          <a:latin typeface="Noto Sans"/>
+                        </a:defRPr>
+                      </a:pPr>
+                      <a:r>
+                        <a:rPr sz="2000" b="0" lang="ja-JP" altLang="en-US">
+                          <a:solidFill>
+                            <a:srgbClr val="303437"/>
+                          </a:solidFill>
+                          <a:latin typeface="Noto Sans"/>
+                          <a:ea typeface="Noto Sans CJK JP"/>
+                          <a:cs typeface="Noto Sans"/>
+                        </a:rPr>
+                        <a:t>1課題に含む不具合の数</a:t>
                       </a:r>
                     </a:p>
                   </a:txBody>
@@ -29513,7 +28781,7 @@
                           <a:ea typeface="Noto Sans CJK JP"/>
                           <a:cs typeface="Noto Sans"/>
                         </a:rPr>
-                        <a:t>顧客：読取／更新</a:t>
+                        <a:t>該当する課題の件数</a:t>
                       </a:r>
                     </a:p>
                   </a:txBody>
@@ -29542,7 +28810,7 @@
                   </a:tcPr>
                 </a:tc>
               </a:tr>
-              <a:tr h="685800">
+              <a:tr h="457200">
                 <a:tc>
                   <a:txBody>
                     <a:bodyPr wrap="square">
@@ -29571,7 +28839,7 @@
                           <a:ea typeface="Noto Sans CJK JP"/>
                           <a:cs typeface="Noto Sans"/>
                         </a:rPr>
-                        <a:t>小売</a:t>
+                        <a:t>6個</a:t>
                       </a:r>
                     </a:p>
                   </a:txBody>
@@ -29624,7 +28892,7 @@
                           <a:ea typeface="Noto Sans CJK JP"/>
                           <a:cs typeface="Noto Sans"/>
                         </a:rPr>
-                        <a:t>6／7</a:t>
+                        <a:t>11件</a:t>
                       </a:r>
                     </a:p>
                   </a:txBody>
@@ -29640,6 +28908,58 @@
                         <a:srgbClr val="626669"/>
                       </a:solidFill>
                       <a:prstDash val="solid"/>
+                    </a:lnT>
+                    <a:lnB w="7620">
+                      <a:noFill/>
+                    </a:lnB>
+                    <a:solidFill>
+                      <a:srgbClr val="FFFEF8"/>
+                    </a:solidFill>
+                  </a:tcPr>
+                </a:tc>
+              </a:tr>
+              <a:tr h="457200">
+                <a:tc>
+                  <a:txBody>
+                    <a:bodyPr wrap="square">
+                      <a:noAutofit/>
+                    </a:bodyPr>
+                    <a:lstStyle/>
+                    <a:p>
+                      <a:pPr algn="l">
+                        <a:lnSpc>
+                          <a:spcPts val="2300"/>
+                        </a:lnSpc>
+                        <a:buNone/>
+                        <a:defRPr sz="2000" b="0">
+                          <a:solidFill>
+                            <a:srgbClr val="303437"/>
+                          </a:solidFill>
+                          <a:latin typeface="Noto Sans"/>
+                        </a:defRPr>
+                      </a:pPr>
+                      <a:r>
+                        <a:rPr sz="2000" b="0" lang="ja-JP" altLang="en-US">
+                          <a:solidFill>
+                            <a:srgbClr val="303437"/>
+                          </a:solidFill>
+                          <a:latin typeface="Noto Sans"/>
+                          <a:ea typeface="Noto Sans CJK JP"/>
+                          <a:cs typeface="Noto Sans"/>
+                        </a:rPr>
+                        <a:t>7個</a:t>
+                      </a:r>
+                    </a:p>
+                  </a:txBody>
+                  <a:tcPr marL="63500" marR="63500" marT="38100" marB="38100" anchor="ctr">
+                    <a:lnL w="7620">
+                      <a:noFill/>
+                    </a:lnL>
+                    <a:lnR w="7620">
+                      <a:noFill/>
+                    </a:lnR>
+                    <a:lnT w="7620">
+                      <a:noFill/>
                     </a:lnT>
                     <a:lnB w="7620">
                       <a:noFill/>
@@ -29677,7 +28997,7 @@
                           <a:ea typeface="Noto Sans CJK JP"/>
                           <a:cs typeface="Noto Sans"/>
                         </a:rPr>
-                        <a:t>なし</a:t>
+                        <a:t>8件</a:t>
                       </a:r>
                     </a:p>
                   </a:txBody>
@@ -29689,10 +29009,7 @@
                       <a:noFill/>
                     </a:lnR>
                     <a:lnT w="7620">
-                      <a:solidFill>
-                        <a:srgbClr val="626669"/>
-                      </a:solidFill>
-                      <a:prstDash val="solid"/>
+                      <a:noFill/>
                     </a:lnT>
                     <a:lnB w="7620">
                       <a:noFill/>
@@ -29703,7 +29020,7 @@
                   </a:tcPr>
                 </a:tc>
               </a:tr>
-              <a:tr h="685800">
+              <a:tr h="457200">
                 <a:tc>
                   <a:txBody>
                     <a:bodyPr wrap="square">
@@ -29732,7 +29049,7 @@
                           <a:ea typeface="Noto Sans CJK JP"/>
                           <a:cs typeface="Noto Sans"/>
                         </a:rPr>
-                        <a:t>航空</a:t>
+                        <a:t>8個</a:t>
                       </a:r>
                     </a:p>
                   </a:txBody>
@@ -29782,7 +29099,7 @@
                           <a:ea typeface="Noto Sans CJK JP"/>
                           <a:cs typeface="Noto Sans"/>
                         </a:rPr>
-                        <a:t>6／6</a:t>
+                        <a:t>4件</a:t>
                       </a:r>
                     </a:p>
                   </a:txBody>
@@ -29804,6 +29121,8 @@
                     </a:solidFill>
                   </a:tcPr>
                 </a:tc>
+              </a:tr>
+              <a:tr h="457200">
                 <a:tc>
                   <a:txBody>
                     <a:bodyPr wrap="square">
@@ -29832,59 +29151,7 @@
                           <a:ea typeface="Noto Sans CJK JP"/>
                           <a:cs typeface="Noto Sans"/>
                         </a:rPr>
-                        <a:t>なし</a:t>
-                      </a:r>
-                    </a:p>
-                  </a:txBody>
-                  <a:tcPr marL="63500" marR="63500" marT="38100" marB="38100" anchor="ctr">
-                    <a:lnL w="7620">
-                      <a:noFill/>
-                    </a:lnL>
-                    <a:lnR w="7620">
-                      <a:noFill/>
-                    </a:lnR>
-                    <a:lnT w="7620">
-                      <a:noFill/>
-                    </a:lnT>
-                    <a:lnB w="7620">
-                      <a:noFill/>
-                    </a:lnB>
-                    <a:solidFill>
-                      <a:srgbClr val="FFFEF8"/>
-                    </a:solidFill>
-                  </a:tcPr>
-                </a:tc>
-              </a:tr>
-              <a:tr h="685800">
-                <a:tc>
-                  <a:txBody>
-                    <a:bodyPr wrap="square">
-                      <a:noAutofit/>
-                    </a:bodyPr>
-                    <a:lstStyle/>
-                    <a:p>
-                      <a:pPr algn="l">
-                        <a:lnSpc>
-                          <a:spcPts val="2300"/>
-                        </a:lnSpc>
-                        <a:buNone/>
-                        <a:defRPr sz="2000" b="0">
-                          <a:solidFill>
-                            <a:srgbClr val="303437"/>
-                          </a:solidFill>
-                          <a:latin typeface="Noto Sans"/>
-                        </a:defRPr>
-                      </a:pPr>
-                      <a:r>
-                        <a:rPr sz="2000" b="0" lang="ja-JP" altLang="en-US">
-                          <a:solidFill>
-                            <a:srgbClr val="303437"/>
-                          </a:solidFill>
-                          <a:latin typeface="Noto Sans"/>
-                          <a:ea typeface="Noto Sans CJK JP"/>
-                          <a:cs typeface="Noto Sans"/>
-                        </a:rPr>
-                        <a:t>通信</a:t>
+                        <a:t>9個</a:t>
                       </a:r>
                     </a:p>
                   </a:txBody>
@@ -29937,7 +29204,1283 @@
                           <a:ea typeface="Noto Sans CJK JP"/>
                           <a:cs typeface="Noto Sans"/>
                         </a:rPr>
-                        <a:t>6／6</a:t>
+                        <a:t>6件</a:t>
+                      </a:r>
+                    </a:p>
+                  </a:txBody>
+                  <a:tcPr marL="63500" marR="63500" marT="38100" marB="38100" anchor="ctr">
+                    <a:lnL w="7620">
+                      <a:noFill/>
+                    </a:lnL>
+                    <a:lnR w="7620">
+                      <a:noFill/>
+                    </a:lnR>
+                    <a:lnT w="7620">
+                      <a:noFill/>
+                    </a:lnT>
+                    <a:lnB w="15240">
+                      <a:solidFill>
+                        <a:srgbClr val="626669"/>
+                      </a:solidFill>
+                      <a:prstDash val="solid"/>
+                    </a:lnB>
+                    <a:solidFill>
+                      <a:srgbClr val="FFFEF8"/>
+                    </a:solidFill>
+                  </a:tcPr>
+                </a:tc>
+              </a:tr>
+            </a:tbl>
+          </a:graphicData>
+        </a:graphic>
+      </p:graphicFrame>
+      <p:sp>
+        <p:nvSpPr>
+          <p:cNvPr id="5" name="TextBox 4"/>
+          <p:cNvSpPr txBox="1"/>
+          <p:nvPr/>
+        </p:nvSpPr>
+        <p:spPr>
+          <a:xfrm>
+            <a:off x="594360" y="4005072"/>
+            <a:ext cx="7955279" cy="685800"/>
+          </a:xfrm>
+          <a:prstGeom prst="rect">
+            <a:avLst/>
+          </a:prstGeom>
+          <a:noFill/>
+        </p:spPr>
+        <p:txBody>
+          <a:bodyPr wrap="square" lIns="0" rIns="0" tIns="0" bIns="0">
+            <a:noAutofit/>
+          </a:bodyPr>
+          <a:lstStyle/>
+          <a:p>
+            <a:pPr algn="l">
+              <a:lnSpc>
+                <a:spcPts val="2160"/>
+              </a:lnSpc>
+              <a:spcBef>
+                <a:spcPts val="0"/>
+              </a:spcBef>
+              <a:spcAft>
+                <a:spcPts val="0"/>
+              </a:spcAft>
+              <a:buNone/>
+              <a:defRPr sz="1800" b="0">
+                <a:solidFill>
+                  <a:srgbClr val="303437"/>
+                </a:solidFill>
+                <a:latin typeface="Noto Sans"/>
+              </a:defRPr>
+            </a:pPr>
+            <a:r>
+              <a:rPr sz="1800" b="0" lang="ja-JP" altLang="en-US">
+                <a:solidFill>
+                  <a:srgbClr val="303437"/>
+                </a:solidFill>
+                <a:latin typeface="Noto Sans"/>
+                <a:ea typeface="Noto Sans CJK JP"/>
+                <a:cs typeface="Noto Sans"/>
+              </a:rPr>
+              <a:t>9個の不具合を組み合わせた課題は6件。</a:t>
+            </a:r>
+          </a:p>
+          <a:p>
+            <a:pPr algn="l">
+              <a:lnSpc>
+                <a:spcPts val="2160"/>
+              </a:lnSpc>
+              <a:spcBef>
+                <a:spcPts val="0"/>
+              </a:spcBef>
+              <a:spcAft>
+                <a:spcPts val="0"/>
+              </a:spcAft>
+              <a:buNone/>
+              <a:defRPr sz="1800" b="0">
+                <a:solidFill>
+                  <a:srgbClr val="303437"/>
+                </a:solidFill>
+                <a:latin typeface="Noto Sans"/>
+              </a:defRPr>
+            </a:pPr>
+            <a:r>
+              <a:rPr sz="1800" b="0" lang="ja-JP" altLang="en-US">
+                <a:solidFill>
+                  <a:srgbClr val="303437"/>
+                </a:solidFill>
+                <a:latin typeface="Noto Sans"/>
+                <a:ea typeface="Noto Sans CJK JP"/>
+                <a:cs typeface="Noto Sans"/>
+              </a:rPr>
+              <a:t>54〜55ページの8行を合計すると、通信課題114件になる。</a:t>
+            </a:r>
+          </a:p>
+        </p:txBody>
+      </p:sp>
+      <p:sp>
+        <p:nvSpPr>
+          <p:cNvPr id="6" name="TextBox 5"/>
+          <p:cNvSpPr txBox="1"/>
+          <p:nvPr/>
+        </p:nvSpPr>
+        <p:spPr>
+          <a:xfrm>
+            <a:off x="502920" y="4690872"/>
+            <a:ext cx="8183879" cy="393192"/>
+          </a:xfrm>
+          <a:prstGeom prst="rect">
+            <a:avLst/>
+          </a:prstGeom>
+          <a:noFill/>
+        </p:spPr>
+        <p:txBody>
+          <a:bodyPr wrap="square" lIns="0" rIns="0" tIns="0" bIns="0">
+            <a:noAutofit/>
+          </a:bodyPr>
+          <a:lstStyle/>
+          <a:p>
+            <a:pPr algn="l">
+              <a:lnSpc>
+                <a:spcPct val="112000"/>
+              </a:lnSpc>
+              <a:spcBef>
+                <a:spcPts val="0"/>
+              </a:spcBef>
+              <a:spcAft>
+                <a:spcPts val="0"/>
+              </a:spcAft>
+              <a:buNone/>
+              <a:defRPr sz="810" b="0">
+                <a:solidFill>
+                  <a:srgbClr val="303437"/>
+                </a:solidFill>
+                <a:latin typeface="Noto Sans"/>
+              </a:defRPr>
+            </a:pPr>
+            <a:r>
+              <a:rPr sz="810" b="0" lang="ja-JP" altLang="en-US">
+                <a:solidFill>
+                  <a:srgbClr val="626669"/>
+                </a:solidFill>
+                <a:latin typeface="Noto Sans"/>
+                <a:ea typeface="Noto Sans CJK JP"/>
+                <a:cs typeface="Noto Sans"/>
+              </a:rPr>
+              <a:t/>
+            </a:r>
+            <a:r>
+              <a:rPr sz="810" b="0" lang="ja-JP" altLang="en-US">
+                <a:solidFill>
+                  <a:srgbClr val="626669"/>
+                </a:solidFill>
+                <a:latin typeface="Noto Sans"/>
+                <a:ea typeface="Noto Sans CJK JP"/>
+                <a:cs typeface="Noto Sans"/>
+              </a:rPr>
+              <a:t>Sierra (2025). τ²-bench. 公開版v0.2.0、278課題。2026-10-16集計。</a:t>
+            </a:r>
+            <a:r>
+              <a:rPr sz="810" b="0" lang="ja-JP" altLang="en-US">
+                <a:solidFill>
+                  <a:srgbClr val="626669"/>
+                </a:solidFill>
+                <a:latin typeface="Noto Sans"/>
+                <a:ea typeface="Noto Sans CJK JP"/>
+                <a:cs typeface="Noto Sans"/>
+              </a:rPr>
+              <a:t>  </a:t>
+            </a:r>
+            <a:r>
+              <a:rPr sz="810" b="0" lang="ja-JP" altLang="en-US">
+                <a:solidFill>
+                  <a:srgbClr val="626669"/>
+                </a:solidFill>
+                <a:latin typeface="Noto Sans"/>
+                <a:ea typeface="Noto Sans CJK JP"/>
+                <a:cs typeface="Noto Sans"/>
+                <a:hlinkClick r:id="rId2"/>
+              </a:rPr>
+              <a:t>https://github.com/sierra-research/tau2-bench/tree/v0.2.0/data/tau2/domains</a:t>
+            </a:r>
+          </a:p>
+        </p:txBody>
+      </p:sp>
+    </p:spTree>
+  </p:cSld>
+  <p:clrMapOvr>
+    <a:masterClrMapping/>
+  </p:clrMapOvr>
+</p:sld>
+</file>
+
+<file path=ppt/slides/slide56.xml><?xml version="1.0" encoding="utf-8"?>
+<p:sld xmlns:a="http://schemas.openxmlformats.org/drawingml/2006/main" xmlns:p="http://schemas.openxmlformats.org/presentationml/2006/main" xmlns:r="http://schemas.openxmlformats.org/officeDocument/2006/relationships">
+  <p:cSld>
+    <p:spTree>
+      <p:nvGrpSpPr>
+        <p:cNvPr id="1" name=""/>
+        <p:cNvGrpSpPr/>
+        <p:nvPr/>
+      </p:nvGrpSpPr>
+      <p:grpSpPr/>
+      <p:sp>
+        <p:nvSpPr>
+          <p:cNvPr id="2" name="Title 1"/>
+          <p:cNvSpPr>
+            <a:spLocks noGrp="1"/>
+          </p:cNvSpPr>
+          <p:nvPr>
+            <p:ph type="title"/>
+          </p:nvPr>
+        </p:nvSpPr>
+        <p:spPr>
+          <a:xfrm>
+            <a:off x="548640" y="786384"/>
+            <a:ext cx="8046720" cy="502920"/>
+          </a:xfrm>
+        </p:spPr>
+        <p:txBody>
+          <a:bodyPr wrap="square" lIns="0" rIns="0" tIns="0" bIns="0">
+            <a:noAutofit/>
+          </a:bodyPr>
+          <a:lstStyle/>
+          <a:p>
+            <a:pPr algn="l">
+              <a:lnSpc>
+                <a:spcPct val="110000"/>
+              </a:lnSpc>
+              <a:buNone/>
+              <a:defRPr sz="2800" b="0">
+                <a:solidFill>
+                  <a:srgbClr val="303437"/>
+                </a:solidFill>
+                <a:latin typeface="Noto Sans"/>
+              </a:defRPr>
+            </a:pPr>
+            <a:r>
+              <a:rPr sz="2800" b="1" lang="ja-JP" altLang="en-US">
+                <a:solidFill>
+                  <a:srgbClr val="303437"/>
+                </a:solidFill>
+                <a:latin typeface="Noto Sans"/>
+                <a:ea typeface="Noto Sans CJK JP"/>
+                <a:cs typeface="Noto Sans"/>
+              </a:rPr>
+              <a:t>領域ごとに使えるツールの種類数</a:t>
+            </a:r>
+          </a:p>
+        </p:txBody>
+      </p:sp>
+      <p:sp>
+        <p:nvSpPr>
+          <p:cNvPr id="3" name="Title 2"/>
+          <p:cNvSpPr>
+            <a:spLocks noGrp="1"/>
+          </p:cNvSpPr>
+          <p:nvPr>
+            <p:ph type="title" idx="2"/>
+          </p:nvPr>
+        </p:nvSpPr>
+        <p:spPr>
+          <a:xfrm>
+            <a:off x="75895" y="0"/>
+            <a:ext cx="8115300" cy="480060"/>
+          </a:xfrm>
+        </p:spPr>
+        <p:txBody>
+          <a:bodyPr wrap="square" lIns="0" rIns="0" tIns="0" bIns="0" anchor="ctr">
+            <a:noAutofit/>
+          </a:bodyPr>
+          <a:lstStyle/>
+          <a:p>
+            <a:pPr algn="l">
+              <a:lnSpc>
+                <a:spcPct val="110000"/>
+              </a:lnSpc>
+              <a:buNone/>
+              <a:defRPr sz="1400" b="0">
+                <a:solidFill>
+                  <a:srgbClr val="303437"/>
+                </a:solidFill>
+                <a:latin typeface="Noto Sans"/>
+              </a:defRPr>
+            </a:pPr>
+            <a:r>
+              <a:rPr sz="1400" b="1" lang="ja-JP" altLang="en-US">
+                <a:solidFill>
+                  <a:srgbClr val="FFFFFF"/>
+                </a:solidFill>
+                <a:latin typeface="Noto Sans"/>
+                <a:ea typeface="Noto Sans CJK JP"/>
+                <a:cs typeface="Noto Sans"/>
+              </a:rPr>
+              <a:t>Appendix: 2. 指標・版・公開データ</a:t>
+            </a:r>
+          </a:p>
+        </p:txBody>
+      </p:sp>
+      <p:graphicFrame>
+        <p:nvGraphicFramePr>
+          <p:cNvPr id="4" name="Table 3"/>
+          <p:cNvGraphicFramePr>
+            <a:graphicFrameLocks noGrp="1"/>
+          </p:cNvGraphicFramePr>
+          <p:nvPr/>
+        </p:nvGraphicFramePr>
+        <p:xfrm>
+          <a:off x="548640" y="1508760"/>
+          <a:ext cx="8046720" cy="2066544"/>
+        </p:xfrm>
+        <a:graphic>
+          <a:graphicData uri="http://schemas.openxmlformats.org/drawingml/2006/table">
+            <a:tbl>
+              <a:tblPr firstRow="0" bandRow="0"/>
+              <a:tblGrid>
+                <a:gridCol w="1097280"/>
+                <a:gridCol w="1737360"/>
+                <a:gridCol w="1737360"/>
+                <a:gridCol w="1737360"/>
+                <a:gridCol w="1737360"/>
+              </a:tblGrid>
+              <a:tr h="475488">
+                <a:tc>
+                  <a:txBody>
+                    <a:bodyPr wrap="square">
+                      <a:noAutofit/>
+                    </a:bodyPr>
+                    <a:lstStyle/>
+                    <a:p>
+                      <a:pPr algn="l">
+                        <a:lnSpc>
+                          <a:spcPts val="2070"/>
+                        </a:lnSpc>
+                        <a:buNone/>
+                        <a:defRPr sz="1800" b="0">
+                          <a:solidFill>
+                            <a:srgbClr val="303437"/>
+                          </a:solidFill>
+                          <a:latin typeface="Noto Sans"/>
+                        </a:defRPr>
+                      </a:pPr>
+                      <a:r>
+                        <a:rPr sz="1800" b="0" lang="ja-JP" altLang="en-US">
+                          <a:solidFill>
+                            <a:srgbClr val="303437"/>
+                          </a:solidFill>
+                          <a:latin typeface="Noto Sans"/>
+                          <a:ea typeface="Noto Sans CJK JP"/>
+                          <a:cs typeface="Noto Sans"/>
+                        </a:rPr>
+                        <a:t>領域</a:t>
+                      </a:r>
+                    </a:p>
+                  </a:txBody>
+                  <a:tcPr marL="63500" marR="63500" marT="38100" marB="38100" anchor="ctr">
+                    <a:lnL w="7620">
+                      <a:noFill/>
+                    </a:lnL>
+                    <a:lnR w="7620">
+                      <a:noFill/>
+                    </a:lnR>
+                    <a:lnT w="15240">
+                      <a:solidFill>
+                        <a:srgbClr val="626669"/>
+                      </a:solidFill>
+                      <a:prstDash val="solid"/>
+                    </a:lnT>
+                    <a:lnB w="7620">
+                      <a:solidFill>
+                        <a:srgbClr val="626669"/>
+                      </a:solidFill>
+                      <a:prstDash val="solid"/>
+                    </a:lnB>
+                    <a:solidFill>
+                      <a:srgbClr val="FFFEF8"/>
+                    </a:solidFill>
+                  </a:tcPr>
+                </a:tc>
+                <a:tc>
+                  <a:txBody>
+                    <a:bodyPr wrap="square">
+                      <a:noAutofit/>
+                    </a:bodyPr>
+                    <a:lstStyle/>
+                    <a:p>
+                      <a:pPr algn="r">
+                        <a:lnSpc>
+                          <a:spcPts val="2070"/>
+                        </a:lnSpc>
+                        <a:buNone/>
+                        <a:defRPr sz="1800" b="0">
+                          <a:solidFill>
+                            <a:srgbClr val="303437"/>
+                          </a:solidFill>
+                          <a:latin typeface="Noto Sans"/>
+                        </a:defRPr>
+                      </a:pPr>
+                      <a:r>
+                        <a:rPr sz="1800" b="0" lang="ja-JP" altLang="en-US">
+                          <a:solidFill>
+                            <a:srgbClr val="303437"/>
+                          </a:solidFill>
+                          <a:latin typeface="Noto Sans"/>
+                          <a:ea typeface="Noto Sans CJK JP"/>
+                          <a:cs typeface="Noto Sans"/>
+                        </a:rPr>
+                        <a:t>担当者の読取</a:t>
+                      </a:r>
+                    </a:p>
+                  </a:txBody>
+                  <a:tcPr marL="63500" marR="63500" marT="38100" marB="38100" anchor="ctr">
+                    <a:lnL w="7620">
+                      <a:noFill/>
+                    </a:lnL>
+                    <a:lnR w="7620">
+                      <a:noFill/>
+                    </a:lnR>
+                    <a:lnT w="15240">
+                      <a:solidFill>
+                        <a:srgbClr val="626669"/>
+                      </a:solidFill>
+                      <a:prstDash val="solid"/>
+                    </a:lnT>
+                    <a:lnB w="7620">
+                      <a:solidFill>
+                        <a:srgbClr val="626669"/>
+                      </a:solidFill>
+                      <a:prstDash val="solid"/>
+                    </a:lnB>
+                    <a:solidFill>
+                      <a:srgbClr val="FFFEF8"/>
+                    </a:solidFill>
+                  </a:tcPr>
+                </a:tc>
+                <a:tc>
+                  <a:txBody>
+                    <a:bodyPr wrap="square">
+                      <a:noAutofit/>
+                    </a:bodyPr>
+                    <a:lstStyle/>
+                    <a:p>
+                      <a:pPr algn="r">
+                        <a:lnSpc>
+                          <a:spcPts val="2070"/>
+                        </a:lnSpc>
+                        <a:buNone/>
+                        <a:defRPr sz="1800" b="0">
+                          <a:solidFill>
+                            <a:srgbClr val="303437"/>
+                          </a:solidFill>
+                          <a:latin typeface="Noto Sans"/>
+                        </a:defRPr>
+                      </a:pPr>
+                      <a:r>
+                        <a:rPr sz="1800" b="0" lang="ja-JP" altLang="en-US">
+                          <a:solidFill>
+                            <a:srgbClr val="303437"/>
+                          </a:solidFill>
+                          <a:latin typeface="Noto Sans"/>
+                          <a:ea typeface="Noto Sans CJK JP"/>
+                          <a:cs typeface="Noto Sans"/>
+                        </a:rPr>
+                        <a:t>担当者の更新</a:t>
+                      </a:r>
+                    </a:p>
+                  </a:txBody>
+                  <a:tcPr marL="63500" marR="63500" marT="38100" marB="38100" anchor="ctr">
+                    <a:lnL w="7620">
+                      <a:noFill/>
+                    </a:lnL>
+                    <a:lnR w="7620">
+                      <a:noFill/>
+                    </a:lnR>
+                    <a:lnT w="15240">
+                      <a:solidFill>
+                        <a:srgbClr val="626669"/>
+                      </a:solidFill>
+                      <a:prstDash val="solid"/>
+                    </a:lnT>
+                    <a:lnB w="7620">
+                      <a:solidFill>
+                        <a:srgbClr val="626669"/>
+                      </a:solidFill>
+                      <a:prstDash val="solid"/>
+                    </a:lnB>
+                    <a:solidFill>
+                      <a:srgbClr val="FFFEF8"/>
+                    </a:solidFill>
+                  </a:tcPr>
+                </a:tc>
+                <a:tc>
+                  <a:txBody>
+                    <a:bodyPr wrap="square">
+                      <a:noAutofit/>
+                    </a:bodyPr>
+                    <a:lstStyle/>
+                    <a:p>
+                      <a:pPr algn="l">
+                        <a:lnSpc>
+                          <a:spcPts val="2070"/>
+                        </a:lnSpc>
+                        <a:buNone/>
+                        <a:defRPr sz="1800" b="0">
+                          <a:solidFill>
+                            <a:srgbClr val="303437"/>
+                          </a:solidFill>
+                          <a:latin typeface="Noto Sans"/>
+                        </a:defRPr>
+                      </a:pPr>
+                      <a:r>
+                        <a:rPr sz="1800" b="0" lang="ja-JP" altLang="en-US">
+                          <a:solidFill>
+                            <a:srgbClr val="303437"/>
+                          </a:solidFill>
+                          <a:latin typeface="Noto Sans"/>
+                          <a:ea typeface="Noto Sans CJK JP"/>
+                          <a:cs typeface="Noto Sans"/>
+                        </a:rPr>
+                        <a:t>顧客の読取</a:t>
+                      </a:r>
+                    </a:p>
+                  </a:txBody>
+                  <a:tcPr marL="63500" marR="63500" marT="38100" marB="38100" anchor="ctr">
+                    <a:lnL w="7620">
+                      <a:noFill/>
+                    </a:lnL>
+                    <a:lnR w="7620">
+                      <a:noFill/>
+                    </a:lnR>
+                    <a:lnT w="15240">
+                      <a:solidFill>
+                        <a:srgbClr val="626669"/>
+                      </a:solidFill>
+                      <a:prstDash val="solid"/>
+                    </a:lnT>
+                    <a:lnB w="7620">
+                      <a:solidFill>
+                        <a:srgbClr val="626669"/>
+                      </a:solidFill>
+                      <a:prstDash val="solid"/>
+                    </a:lnB>
+                    <a:solidFill>
+                      <a:srgbClr val="FFFEF8"/>
+                    </a:solidFill>
+                  </a:tcPr>
+                </a:tc>
+                <a:tc>
+                  <a:txBody>
+                    <a:bodyPr wrap="square">
+                      <a:noAutofit/>
+                    </a:bodyPr>
+                    <a:lstStyle/>
+                    <a:p>
+                      <a:pPr algn="l">
+                        <a:lnSpc>
+                          <a:spcPts val="2070"/>
+                        </a:lnSpc>
+                        <a:buNone/>
+                        <a:defRPr sz="1800" b="0">
+                          <a:solidFill>
+                            <a:srgbClr val="303437"/>
+                          </a:solidFill>
+                          <a:latin typeface="Noto Sans"/>
+                        </a:defRPr>
+                      </a:pPr>
+                      <a:r>
+                        <a:rPr sz="1800" b="0" lang="ja-JP" altLang="en-US">
+                          <a:solidFill>
+                            <a:srgbClr val="303437"/>
+                          </a:solidFill>
+                          <a:latin typeface="Noto Sans"/>
+                          <a:ea typeface="Noto Sans CJK JP"/>
+                          <a:cs typeface="Noto Sans"/>
+                        </a:rPr>
+                        <a:t>顧客の更新</a:t>
+                      </a:r>
+                    </a:p>
+                  </a:txBody>
+                  <a:tcPr marL="63500" marR="63500" marT="38100" marB="38100" anchor="ctr">
+                    <a:lnL w="7620">
+                      <a:noFill/>
+                    </a:lnL>
+                    <a:lnR w="7620">
+                      <a:noFill/>
+                    </a:lnR>
+                    <a:lnT w="15240">
+                      <a:solidFill>
+                        <a:srgbClr val="626669"/>
+                      </a:solidFill>
+                      <a:prstDash val="solid"/>
+                    </a:lnT>
+                    <a:lnB w="7620">
+                      <a:solidFill>
+                        <a:srgbClr val="626669"/>
+                      </a:solidFill>
+                      <a:prstDash val="solid"/>
+                    </a:lnB>
+                    <a:solidFill>
+                      <a:srgbClr val="FFFEF8"/>
+                    </a:solidFill>
+                  </a:tcPr>
+                </a:tc>
+              </a:tr>
+              <a:tr h="530352">
+                <a:tc>
+                  <a:txBody>
+                    <a:bodyPr wrap="square">
+                      <a:noAutofit/>
+                    </a:bodyPr>
+                    <a:lstStyle/>
+                    <a:p>
+                      <a:pPr algn="l">
+                        <a:lnSpc>
+                          <a:spcPts val="2070"/>
+                        </a:lnSpc>
+                        <a:buNone/>
+                        <a:defRPr sz="1800" b="0">
+                          <a:solidFill>
+                            <a:srgbClr val="303437"/>
+                          </a:solidFill>
+                          <a:latin typeface="Noto Sans"/>
+                        </a:defRPr>
+                      </a:pPr>
+                      <a:r>
+                        <a:rPr sz="1800" b="0" lang="ja-JP" altLang="en-US">
+                          <a:solidFill>
+                            <a:srgbClr val="303437"/>
+                          </a:solidFill>
+                          <a:latin typeface="Noto Sans"/>
+                          <a:ea typeface="Noto Sans CJK JP"/>
+                          <a:cs typeface="Noto Sans"/>
+                        </a:rPr>
+                        <a:t>小売</a:t>
+                      </a:r>
+                    </a:p>
+                  </a:txBody>
+                  <a:tcPr marL="63500" marR="63500" marT="38100" marB="38100" anchor="ctr">
+                    <a:lnL w="7620">
+                      <a:noFill/>
+                    </a:lnL>
+                    <a:lnR w="7620">
+                      <a:noFill/>
+                    </a:lnR>
+                    <a:lnT w="7620">
+                      <a:solidFill>
+                        <a:srgbClr val="626669"/>
+                      </a:solidFill>
+                      <a:prstDash val="solid"/>
+                    </a:lnT>
+                    <a:lnB w="7620">
+                      <a:noFill/>
+                    </a:lnB>
+                    <a:solidFill>
+                      <a:srgbClr val="FFFEF8"/>
+                    </a:solidFill>
+                  </a:tcPr>
+                </a:tc>
+                <a:tc>
+                  <a:txBody>
+                    <a:bodyPr wrap="square">
+                      <a:noAutofit/>
+                    </a:bodyPr>
+                    <a:lstStyle/>
+                    <a:p>
+                      <a:pPr algn="r">
+                        <a:lnSpc>
+                          <a:spcPts val="2070"/>
+                        </a:lnSpc>
+                        <a:buNone/>
+                        <a:defRPr sz="1800" b="0">
+                          <a:solidFill>
+                            <a:srgbClr val="303437"/>
+                          </a:solidFill>
+                          <a:latin typeface="Noto Sans"/>
+                        </a:defRPr>
+                      </a:pPr>
+                      <a:r>
+                        <a:rPr sz="1800" b="0" lang="ja-JP" altLang="en-US">
+                          <a:solidFill>
+                            <a:srgbClr val="303437"/>
+                          </a:solidFill>
+                          <a:latin typeface="Noto Sans"/>
+                          <a:ea typeface="Noto Sans CJK JP"/>
+                          <a:cs typeface="Noto Sans"/>
+                        </a:rPr>
+                        <a:t>6</a:t>
+                      </a:r>
+                    </a:p>
+                  </a:txBody>
+                  <a:tcPr marL="63500" marR="63500" marT="38100" marB="38100" anchor="ctr">
+                    <a:lnL w="7620">
+                      <a:noFill/>
+                    </a:lnL>
+                    <a:lnR w="7620">
+                      <a:noFill/>
+                    </a:lnR>
+                    <a:lnT w="7620">
+                      <a:solidFill>
+                        <a:srgbClr val="626669"/>
+                      </a:solidFill>
+                      <a:prstDash val="solid"/>
+                    </a:lnT>
+                    <a:lnB w="7620">
+                      <a:noFill/>
+                    </a:lnB>
+                    <a:solidFill>
+                      <a:srgbClr val="FFFEF8"/>
+                    </a:solidFill>
+                  </a:tcPr>
+                </a:tc>
+                <a:tc>
+                  <a:txBody>
+                    <a:bodyPr wrap="square">
+                      <a:noAutofit/>
+                    </a:bodyPr>
+                    <a:lstStyle/>
+                    <a:p>
+                      <a:pPr algn="r">
+                        <a:lnSpc>
+                          <a:spcPts val="2070"/>
+                        </a:lnSpc>
+                        <a:buNone/>
+                        <a:defRPr sz="1800" b="0">
+                          <a:solidFill>
+                            <a:srgbClr val="303437"/>
+                          </a:solidFill>
+                          <a:latin typeface="Noto Sans"/>
+                        </a:defRPr>
+                      </a:pPr>
+                      <a:r>
+                        <a:rPr sz="1800" b="0" lang="ja-JP" altLang="en-US">
+                          <a:solidFill>
+                            <a:srgbClr val="303437"/>
+                          </a:solidFill>
+                          <a:latin typeface="Noto Sans"/>
+                          <a:ea typeface="Noto Sans CJK JP"/>
+                          <a:cs typeface="Noto Sans"/>
+                        </a:rPr>
+                        <a:t>7</a:t>
+                      </a:r>
+                    </a:p>
+                  </a:txBody>
+                  <a:tcPr marL="63500" marR="63500" marT="38100" marB="38100" anchor="ctr">
+                    <a:lnL w="7620">
+                      <a:noFill/>
+                    </a:lnL>
+                    <a:lnR w="7620">
+                      <a:noFill/>
+                    </a:lnR>
+                    <a:lnT w="7620">
+                      <a:solidFill>
+                        <a:srgbClr val="626669"/>
+                      </a:solidFill>
+                      <a:prstDash val="solid"/>
+                    </a:lnT>
+                    <a:lnB w="7620">
+                      <a:noFill/>
+                    </a:lnB>
+                    <a:solidFill>
+                      <a:srgbClr val="FFFEF8"/>
+                    </a:solidFill>
+                  </a:tcPr>
+                </a:tc>
+                <a:tc>
+                  <a:txBody>
+                    <a:bodyPr wrap="square">
+                      <a:noAutofit/>
+                    </a:bodyPr>
+                    <a:lstStyle/>
+                    <a:p>
+                      <a:pPr algn="l">
+                        <a:lnSpc>
+                          <a:spcPts val="2070"/>
+                        </a:lnSpc>
+                        <a:buNone/>
+                        <a:defRPr sz="1800" b="0">
+                          <a:solidFill>
+                            <a:srgbClr val="303437"/>
+                          </a:solidFill>
+                          <a:latin typeface="Noto Sans"/>
+                        </a:defRPr>
+                      </a:pPr>
+                      <a:r>
+                        <a:rPr sz="1800" b="0" lang="ja-JP" altLang="en-US">
+                          <a:solidFill>
+                            <a:srgbClr val="303437"/>
+                          </a:solidFill>
+                          <a:latin typeface="Noto Sans"/>
+                          <a:ea typeface="Noto Sans CJK JP"/>
+                          <a:cs typeface="Noto Sans"/>
+                        </a:rPr>
+                        <a:t>なし</a:t>
+                      </a:r>
+                    </a:p>
+                  </a:txBody>
+                  <a:tcPr marL="63500" marR="63500" marT="38100" marB="38100" anchor="ctr">
+                    <a:lnL w="7620">
+                      <a:noFill/>
+                    </a:lnL>
+                    <a:lnR w="7620">
+                      <a:noFill/>
+                    </a:lnR>
+                    <a:lnT w="7620">
+                      <a:solidFill>
+                        <a:srgbClr val="626669"/>
+                      </a:solidFill>
+                      <a:prstDash val="solid"/>
+                    </a:lnT>
+                    <a:lnB w="7620">
+                      <a:noFill/>
+                    </a:lnB>
+                    <a:solidFill>
+                      <a:srgbClr val="FFFEF8"/>
+                    </a:solidFill>
+                  </a:tcPr>
+                </a:tc>
+                <a:tc>
+                  <a:txBody>
+                    <a:bodyPr wrap="square">
+                      <a:noAutofit/>
+                    </a:bodyPr>
+                    <a:lstStyle/>
+                    <a:p>
+                      <a:pPr algn="l">
+                        <a:lnSpc>
+                          <a:spcPts val="2070"/>
+                        </a:lnSpc>
+                        <a:buNone/>
+                        <a:defRPr sz="1800" b="0">
+                          <a:solidFill>
+                            <a:srgbClr val="303437"/>
+                          </a:solidFill>
+                          <a:latin typeface="Noto Sans"/>
+                        </a:defRPr>
+                      </a:pPr>
+                      <a:r>
+                        <a:rPr sz="1800" b="0" lang="ja-JP" altLang="en-US">
+                          <a:solidFill>
+                            <a:srgbClr val="303437"/>
+                          </a:solidFill>
+                          <a:latin typeface="Noto Sans"/>
+                          <a:ea typeface="Noto Sans CJK JP"/>
+                          <a:cs typeface="Noto Sans"/>
+                        </a:rPr>
+                        <a:t>なし</a:t>
+                      </a:r>
+                    </a:p>
+                  </a:txBody>
+                  <a:tcPr marL="63500" marR="63500" marT="38100" marB="38100" anchor="ctr">
+                    <a:lnL w="7620">
+                      <a:noFill/>
+                    </a:lnL>
+                    <a:lnR w="7620">
+                      <a:noFill/>
+                    </a:lnR>
+                    <a:lnT w="7620">
+                      <a:solidFill>
+                        <a:srgbClr val="626669"/>
+                      </a:solidFill>
+                      <a:prstDash val="solid"/>
+                    </a:lnT>
+                    <a:lnB w="7620">
+                      <a:noFill/>
+                    </a:lnB>
+                    <a:solidFill>
+                      <a:srgbClr val="FFFEF8"/>
+                    </a:solidFill>
+                  </a:tcPr>
+                </a:tc>
+              </a:tr>
+              <a:tr h="530352">
+                <a:tc>
+                  <a:txBody>
+                    <a:bodyPr wrap="square">
+                      <a:noAutofit/>
+                    </a:bodyPr>
+                    <a:lstStyle/>
+                    <a:p>
+                      <a:pPr algn="l">
+                        <a:lnSpc>
+                          <a:spcPts val="2070"/>
+                        </a:lnSpc>
+                        <a:buNone/>
+                        <a:defRPr sz="1800" b="0">
+                          <a:solidFill>
+                            <a:srgbClr val="303437"/>
+                          </a:solidFill>
+                          <a:latin typeface="Noto Sans"/>
+                        </a:defRPr>
+                      </a:pPr>
+                      <a:r>
+                        <a:rPr sz="1800" b="0" lang="ja-JP" altLang="en-US">
+                          <a:solidFill>
+                            <a:srgbClr val="303437"/>
+                          </a:solidFill>
+                          <a:latin typeface="Noto Sans"/>
+                          <a:ea typeface="Noto Sans CJK JP"/>
+                          <a:cs typeface="Noto Sans"/>
+                        </a:rPr>
+                        <a:t>航空</a:t>
+                      </a:r>
+                    </a:p>
+                  </a:txBody>
+                  <a:tcPr marL="63500" marR="63500" marT="38100" marB="38100" anchor="ctr">
+                    <a:lnL w="7620">
+                      <a:noFill/>
+                    </a:lnL>
+                    <a:lnR w="7620">
+                      <a:noFill/>
+                    </a:lnR>
+                    <a:lnT w="7620">
+                      <a:noFill/>
+                    </a:lnT>
+                    <a:lnB w="7620">
+                      <a:noFill/>
+                    </a:lnB>
+                    <a:solidFill>
+                      <a:srgbClr val="FFFEF8"/>
+                    </a:solidFill>
+                  </a:tcPr>
+                </a:tc>
+                <a:tc>
+                  <a:txBody>
+                    <a:bodyPr wrap="square">
+                      <a:noAutofit/>
+                    </a:bodyPr>
+                    <a:lstStyle/>
+                    <a:p>
+                      <a:pPr algn="r">
+                        <a:lnSpc>
+                          <a:spcPts val="2070"/>
+                        </a:lnSpc>
+                        <a:buNone/>
+                        <a:defRPr sz="1800" b="0">
+                          <a:solidFill>
+                            <a:srgbClr val="303437"/>
+                          </a:solidFill>
+                          <a:latin typeface="Noto Sans"/>
+                        </a:defRPr>
+                      </a:pPr>
+                      <a:r>
+                        <a:rPr sz="1800" b="0" lang="ja-JP" altLang="en-US">
+                          <a:solidFill>
+                            <a:srgbClr val="303437"/>
+                          </a:solidFill>
+                          <a:latin typeface="Noto Sans"/>
+                          <a:ea typeface="Noto Sans CJK JP"/>
+                          <a:cs typeface="Noto Sans"/>
+                        </a:rPr>
+                        <a:t>6</a:t>
+                      </a:r>
+                    </a:p>
+                  </a:txBody>
+                  <a:tcPr marL="63500" marR="63500" marT="38100" marB="38100" anchor="ctr">
+                    <a:lnL w="7620">
+                      <a:noFill/>
+                    </a:lnL>
+                    <a:lnR w="7620">
+                      <a:noFill/>
+                    </a:lnR>
+                    <a:lnT w="7620">
+                      <a:noFill/>
+                    </a:lnT>
+                    <a:lnB w="7620">
+                      <a:noFill/>
+                    </a:lnB>
+                    <a:solidFill>
+                      <a:srgbClr val="FFFEF8"/>
+                    </a:solidFill>
+                  </a:tcPr>
+                </a:tc>
+                <a:tc>
+                  <a:txBody>
+                    <a:bodyPr wrap="square">
+                      <a:noAutofit/>
+                    </a:bodyPr>
+                    <a:lstStyle/>
+                    <a:p>
+                      <a:pPr algn="r">
+                        <a:lnSpc>
+                          <a:spcPts val="2070"/>
+                        </a:lnSpc>
+                        <a:buNone/>
+                        <a:defRPr sz="1800" b="0">
+                          <a:solidFill>
+                            <a:srgbClr val="303437"/>
+                          </a:solidFill>
+                          <a:latin typeface="Noto Sans"/>
+                        </a:defRPr>
+                      </a:pPr>
+                      <a:r>
+                        <a:rPr sz="1800" b="0" lang="ja-JP" altLang="en-US">
+                          <a:solidFill>
+                            <a:srgbClr val="303437"/>
+                          </a:solidFill>
+                          <a:latin typeface="Noto Sans"/>
+                          <a:ea typeface="Noto Sans CJK JP"/>
+                          <a:cs typeface="Noto Sans"/>
+                        </a:rPr>
+                        <a:t>6</a:t>
+                      </a:r>
+                    </a:p>
+                  </a:txBody>
+                  <a:tcPr marL="63500" marR="63500" marT="38100" marB="38100" anchor="ctr">
+                    <a:lnL w="7620">
+                      <a:noFill/>
+                    </a:lnL>
+                    <a:lnR w="7620">
+                      <a:noFill/>
+                    </a:lnR>
+                    <a:lnT w="7620">
+                      <a:noFill/>
+                    </a:lnT>
+                    <a:lnB w="7620">
+                      <a:noFill/>
+                    </a:lnB>
+                    <a:solidFill>
+                      <a:srgbClr val="FFFEF8"/>
+                    </a:solidFill>
+                  </a:tcPr>
+                </a:tc>
+                <a:tc>
+                  <a:txBody>
+                    <a:bodyPr wrap="square">
+                      <a:noAutofit/>
+                    </a:bodyPr>
+                    <a:lstStyle/>
+                    <a:p>
+                      <a:pPr algn="l">
+                        <a:lnSpc>
+                          <a:spcPts val="2070"/>
+                        </a:lnSpc>
+                        <a:buNone/>
+                        <a:defRPr sz="1800" b="0">
+                          <a:solidFill>
+                            <a:srgbClr val="303437"/>
+                          </a:solidFill>
+                          <a:latin typeface="Noto Sans"/>
+                        </a:defRPr>
+                      </a:pPr>
+                      <a:r>
+                        <a:rPr sz="1800" b="0" lang="ja-JP" altLang="en-US">
+                          <a:solidFill>
+                            <a:srgbClr val="303437"/>
+                          </a:solidFill>
+                          <a:latin typeface="Noto Sans"/>
+                          <a:ea typeface="Noto Sans CJK JP"/>
+                          <a:cs typeface="Noto Sans"/>
+                        </a:rPr>
+                        <a:t>なし</a:t>
+                      </a:r>
+                    </a:p>
+                  </a:txBody>
+                  <a:tcPr marL="63500" marR="63500" marT="38100" marB="38100" anchor="ctr">
+                    <a:lnL w="7620">
+                      <a:noFill/>
+                    </a:lnL>
+                    <a:lnR w="7620">
+                      <a:noFill/>
+                    </a:lnR>
+                    <a:lnT w="7620">
+                      <a:noFill/>
+                    </a:lnT>
+                    <a:lnB w="7620">
+                      <a:noFill/>
+                    </a:lnB>
+                    <a:solidFill>
+                      <a:srgbClr val="FFFEF8"/>
+                    </a:solidFill>
+                  </a:tcPr>
+                </a:tc>
+                <a:tc>
+                  <a:txBody>
+                    <a:bodyPr wrap="square">
+                      <a:noAutofit/>
+                    </a:bodyPr>
+                    <a:lstStyle/>
+                    <a:p>
+                      <a:pPr algn="l">
+                        <a:lnSpc>
+                          <a:spcPts val="2070"/>
+                        </a:lnSpc>
+                        <a:buNone/>
+                        <a:defRPr sz="1800" b="0">
+                          <a:solidFill>
+                            <a:srgbClr val="303437"/>
+                          </a:solidFill>
+                          <a:latin typeface="Noto Sans"/>
+                        </a:defRPr>
+                      </a:pPr>
+                      <a:r>
+                        <a:rPr sz="1800" b="0" lang="ja-JP" altLang="en-US">
+                          <a:solidFill>
+                            <a:srgbClr val="303437"/>
+                          </a:solidFill>
+                          <a:latin typeface="Noto Sans"/>
+                          <a:ea typeface="Noto Sans CJK JP"/>
+                          <a:cs typeface="Noto Sans"/>
+                        </a:rPr>
+                        <a:t>なし</a:t>
+                      </a:r>
+                    </a:p>
+                  </a:txBody>
+                  <a:tcPr marL="63500" marR="63500" marT="38100" marB="38100" anchor="ctr">
+                    <a:lnL w="7620">
+                      <a:noFill/>
+                    </a:lnL>
+                    <a:lnR w="7620">
+                      <a:noFill/>
+                    </a:lnR>
+                    <a:lnT w="7620">
+                      <a:noFill/>
+                    </a:lnT>
+                    <a:lnB w="7620">
+                      <a:noFill/>
+                    </a:lnB>
+                    <a:solidFill>
+                      <a:srgbClr val="FFFEF8"/>
+                    </a:solidFill>
+                  </a:tcPr>
+                </a:tc>
+              </a:tr>
+              <a:tr h="530352">
+                <a:tc>
+                  <a:txBody>
+                    <a:bodyPr wrap="square">
+                      <a:noAutofit/>
+                    </a:bodyPr>
+                    <a:lstStyle/>
+                    <a:p>
+                      <a:pPr algn="l">
+                        <a:lnSpc>
+                          <a:spcPts val="2070"/>
+                        </a:lnSpc>
+                        <a:buNone/>
+                        <a:defRPr sz="1800" b="0">
+                          <a:solidFill>
+                            <a:srgbClr val="303437"/>
+                          </a:solidFill>
+                          <a:latin typeface="Noto Sans"/>
+                        </a:defRPr>
+                      </a:pPr>
+                      <a:r>
+                        <a:rPr sz="1800" b="0" lang="ja-JP" altLang="en-US">
+                          <a:solidFill>
+                            <a:srgbClr val="303437"/>
+                          </a:solidFill>
+                          <a:latin typeface="Noto Sans"/>
+                          <a:ea typeface="Noto Sans CJK JP"/>
+                          <a:cs typeface="Noto Sans"/>
+                        </a:rPr>
+                        <a:t>通信</a:t>
+                      </a:r>
+                    </a:p>
+                  </a:txBody>
+                  <a:tcPr marL="63500" marR="63500" marT="38100" marB="38100" anchor="ctr">
+                    <a:lnL w="7620">
+                      <a:noFill/>
+                    </a:lnL>
+                    <a:lnR w="7620">
+                      <a:noFill/>
+                    </a:lnR>
+                    <a:lnT w="7620">
+                      <a:noFill/>
+                    </a:lnT>
+                    <a:lnB w="15240">
+                      <a:solidFill>
+                        <a:srgbClr val="626669"/>
+                      </a:solidFill>
+                      <a:prstDash val="solid"/>
+                    </a:lnB>
+                    <a:solidFill>
+                      <a:srgbClr val="FFFEF8"/>
+                    </a:solidFill>
+                  </a:tcPr>
+                </a:tc>
+                <a:tc>
+                  <a:txBody>
+                    <a:bodyPr wrap="square">
+                      <a:noAutofit/>
+                    </a:bodyPr>
+                    <a:lstStyle/>
+                    <a:p>
+                      <a:pPr algn="r">
+                        <a:lnSpc>
+                          <a:spcPts val="2070"/>
+                        </a:lnSpc>
+                        <a:buNone/>
+                        <a:defRPr sz="1800" b="0">
+                          <a:solidFill>
+                            <a:srgbClr val="303437"/>
+                          </a:solidFill>
+                          <a:latin typeface="Noto Sans"/>
+                        </a:defRPr>
+                      </a:pPr>
+                      <a:r>
+                        <a:rPr sz="1800" b="0" lang="ja-JP" altLang="en-US">
+                          <a:solidFill>
+                            <a:srgbClr val="303437"/>
+                          </a:solidFill>
+                          <a:latin typeface="Noto Sans"/>
+                          <a:ea typeface="Noto Sans CJK JP"/>
+                          <a:cs typeface="Noto Sans"/>
+                        </a:rPr>
+                        <a:t>6</a:t>
+                      </a:r>
+                    </a:p>
+                  </a:txBody>
+                  <a:tcPr marL="63500" marR="63500" marT="38100" marB="38100" anchor="ctr">
+                    <a:lnL w="7620">
+                      <a:noFill/>
+                    </a:lnL>
+                    <a:lnR w="7620">
+                      <a:noFill/>
+                    </a:lnR>
+                    <a:lnT w="7620">
+                      <a:noFill/>
+                    </a:lnT>
+                    <a:lnB w="15240">
+                      <a:solidFill>
+                        <a:srgbClr val="626669"/>
+                      </a:solidFill>
+                      <a:prstDash val="solid"/>
+                    </a:lnB>
+                    <a:solidFill>
+                      <a:srgbClr val="FFFEF8"/>
+                    </a:solidFill>
+                  </a:tcPr>
+                </a:tc>
+                <a:tc>
+                  <a:txBody>
+                    <a:bodyPr wrap="square">
+                      <a:noAutofit/>
+                    </a:bodyPr>
+                    <a:lstStyle/>
+                    <a:p>
+                      <a:pPr algn="r">
+                        <a:lnSpc>
+                          <a:spcPts val="2070"/>
+                        </a:lnSpc>
+                        <a:buNone/>
+                        <a:defRPr sz="1800" b="0">
+                          <a:solidFill>
+                            <a:srgbClr val="303437"/>
+                          </a:solidFill>
+                          <a:latin typeface="Noto Sans"/>
+                        </a:defRPr>
+                      </a:pPr>
+                      <a:r>
+                        <a:rPr sz="1800" b="0" lang="ja-JP" altLang="en-US">
+                          <a:solidFill>
+                            <a:srgbClr val="303437"/>
+                          </a:solidFill>
+                          <a:latin typeface="Noto Sans"/>
+                          <a:ea typeface="Noto Sans CJK JP"/>
+                          <a:cs typeface="Noto Sans"/>
+                        </a:rPr>
+                        <a:t>6</a:t>
                       </a:r>
                     </a:p>
                   </a:txBody>
@@ -29971,10 +30514,10 @@
                     <a:p>
                       <a:pPr algn="l">
                         <a:lnSpc>
-                          <a:spcPts val="2300"/>
+                          <a:spcPts val="2070"/>
                         </a:lnSpc>
                         <a:buNone/>
-                        <a:defRPr sz="2000" b="0">
+                        <a:defRPr sz="1800" b="0">
                           <a:solidFill>
                             <a:srgbClr val="303437"/>
                           </a:solidFill>
@@ -29982,7 +30525,7 @@
                         </a:defRPr>
                       </a:pPr>
                       <a:r>
-                        <a:rPr sz="2000" b="0" lang="ja-JP" altLang="en-US">
+                        <a:rPr sz="1800" b="0" lang="ja-JP" altLang="en-US">
                           <a:solidFill>
                             <a:srgbClr val="303437"/>
                           </a:solidFill>
@@ -29990,7 +30533,60 @@
                           <a:ea typeface="Noto Sans CJK JP"/>
                           <a:cs typeface="Noto Sans"/>
                         </a:rPr>
-                        <a:t>15／15</a:t>
+                        <a:t>15</a:t>
+                      </a:r>
+                    </a:p>
+                  </a:txBody>
+                  <a:tcPr marL="63500" marR="63500" marT="38100" marB="38100" anchor="ctr">
+                    <a:lnL w="7620">
+                      <a:noFill/>
+                    </a:lnL>
+                    <a:lnR w="7620">
+                      <a:noFill/>
+                    </a:lnR>
+                    <a:lnT w="7620">
+                      <a:noFill/>
+                    </a:lnT>
+                    <a:lnB w="15240">
+                      <a:solidFill>
+                        <a:srgbClr val="626669"/>
+                      </a:solidFill>
+                      <a:prstDash val="solid"/>
+                    </a:lnB>
+                    <a:solidFill>
+                      <a:srgbClr val="FFFEF8"/>
+                    </a:solidFill>
+                  </a:tcPr>
+                </a:tc>
+                <a:tc>
+                  <a:txBody>
+                    <a:bodyPr wrap="square">
+                      <a:noAutofit/>
+                    </a:bodyPr>
+                    <a:lstStyle/>
+                    <a:p>
+                      <a:pPr algn="l">
+                        <a:lnSpc>
+                          <a:spcPts val="2070"/>
+                        </a:lnSpc>
+                        <a:buNone/>
+                        <a:defRPr sz="1800" b="0">
+                          <a:solidFill>
+                            <a:srgbClr val="303437"/>
+                          </a:solidFill>
+                          <a:latin typeface="Noto Sans"/>
+                        </a:defRPr>
+                      </a:pPr>
+                      <a:r>
+                        <a:rPr sz="1800" b="0" lang="ja-JP" altLang="en-US">
+                          <a:solidFill>
+                            <a:srgbClr val="303437"/>
+                          </a:solidFill>
+                          <a:latin typeface="Noto Sans"/>
+                          <a:ea typeface="Noto Sans CJK JP"/>
+                          <a:cs typeface="Noto Sans"/>
+                        </a:rPr>
+                        <a:t>15</a:t>
                       </a:r>
                     </a:p>
                   </a:txBody>
@@ -30023,6 +30619,91 @@
       <p:sp>
         <p:nvSpPr>
           <p:cNvPr id="5" name="TextBox 4"/>
+          <p:cNvSpPr txBox="1"/>
+          <p:nvPr/>
+        </p:nvSpPr>
+        <p:spPr>
+          <a:xfrm>
+            <a:off x="594360" y="3767328"/>
+            <a:ext cx="7955279" cy="685800"/>
+          </a:xfrm>
+          <a:prstGeom prst="rect">
+            <a:avLst/>
+          </a:prstGeom>
+          <a:noFill/>
+        </p:spPr>
+        <p:txBody>
+          <a:bodyPr wrap="square" lIns="0" rIns="0" tIns="0" bIns="0">
+            <a:noAutofit/>
+          </a:bodyPr>
+          <a:lstStyle/>
+          <a:p>
+            <a:pPr algn="l">
+              <a:lnSpc>
+                <a:spcPts val="2160"/>
+              </a:lnSpc>
+              <a:spcBef>
+                <a:spcPts val="0"/>
+              </a:spcBef>
+              <a:spcAft>
+                <a:spcPts val="0"/>
+              </a:spcAft>
+              <a:buNone/>
+              <a:defRPr sz="1800" b="0">
+                <a:solidFill>
+                  <a:srgbClr val="303437"/>
+                </a:solidFill>
+                <a:latin typeface="Noto Sans"/>
+              </a:defRPr>
+            </a:pPr>
+            <a:r>
+              <a:rPr sz="1800" b="0" lang="ja-JP" altLang="en-US">
+                <a:solidFill>
+                  <a:srgbClr val="303437"/>
+                </a:solidFill>
+                <a:latin typeface="Noto Sans"/>
+                <a:ea typeface="Noto Sans CJK JP"/>
+                <a:cs typeface="Noto Sans"/>
+              </a:rPr>
+              <a:t>通信の例：読取は契約情報や端末の状態を確認する。</a:t>
+            </a:r>
+          </a:p>
+          <a:p>
+            <a:pPr algn="l">
+              <a:lnSpc>
+                <a:spcPts val="2160"/>
+              </a:lnSpc>
+              <a:spcBef>
+                <a:spcPts val="0"/>
+              </a:spcBef>
+              <a:spcAft>
+                <a:spcPts val="0"/>
+              </a:spcAft>
+              <a:buNone/>
+              <a:defRPr sz="1800" b="0">
+                <a:solidFill>
+                  <a:srgbClr val="303437"/>
+                </a:solidFill>
+                <a:latin typeface="Noto Sans"/>
+              </a:defRPr>
+            </a:pPr>
+            <a:r>
+              <a:rPr sz="1800" b="0" lang="ja-JP" altLang="en-US">
+                <a:solidFill>
+                  <a:srgbClr val="303437"/>
+                </a:solidFill>
+                <a:latin typeface="Noto Sans"/>
+                <a:ea typeface="Noto Sans CJK JP"/>
+                <a:cs typeface="Noto Sans"/>
+              </a:rPr>
+              <a:t>更新は担当者がデータ容量を追加し、顧客が通信をONにする。</a:t>
+            </a:r>
+          </a:p>
+        </p:txBody>
+      </p:sp>
+      <p:sp>
+        <p:nvSpPr>
+          <p:cNvPr id="6" name="TextBox 5"/>
           <p:cNvSpPr txBox="1"/>
           <p:nvPr/>
         </p:nvSpPr>

</xml_diff>

<commit_message>
Proofread tau2-bench with Japanese proofreading skill
</commit_message>
<xml_diff>
--- a/slides/datasets-in-10-minutes-tau2-bench.pptx
+++ b/slides/datasets-in-10-minutes-tau2-bench.pptx
@@ -9879,7 +9879,7 @@
                           <a:ea typeface="Noto Sans CJK JP"/>
                           <a:cs typeface="Noto Sans"/>
                         </a:rPr>
-                        <a:t>他の今後の予約について総額を調べる</a:t>
+                        <a:t>今後の他の予約について総額を調べる</a:t>
                       </a:r>
                     </a:p>
                   </a:txBody>
@@ -12860,7 +12860,7 @@
                           <a:ea typeface="Noto Sans CJK JP"/>
                           <a:cs typeface="Noto Sans"/>
                         </a:rPr>
-                        <a:t>モデル（Google公表表）</a:t>
+                        <a:t>モデル（Google公表値）</a:t>
                       </a:r>
                     </a:p>
                   </a:txBody>
@@ -17421,7 +17421,7 @@
                 <a:ea typeface="Noto Sans CJK JP"/>
                 <a:cs typeface="Noto Sans"/>
               </a:rPr>
-              <a:t>横軸は課題数。各区分は課題IDに含む基本問題の数。全114課題。</a:t>
+              <a:t>横軸は課題数。各区分は課題IDに含まれる基本問題の数。全114課題。</a:t>
             </a:r>
           </a:p>
         </p:txBody>
@@ -20078,7 +20078,7 @@
                           <a:ea typeface="Noto Sans CJK JP"/>
                           <a:cs typeface="Noto Sans"/>
                         </a:rPr>
-                        <a:t>顧客への確認</a:t>
+                        <a:t>顧客の状況</a:t>
                       </a:r>
                     </a:p>
                   </a:txBody>
@@ -21772,7 +21772,7 @@
                 <a:ea typeface="Noto Sans CJK JP"/>
                 <a:cs typeface="Noto Sans"/>
               </a:rPr>
-              <a:t>τ³-benchは、ソフトウェアではv1.0.1として配布される。ベンチマークの系列名と、実装の版番号はこの対応になる。</a:t>
+              <a:t>τ³-benchは、ソフトウェアではv1.0.1として配布される。ベンチマークの系列名と、実装のバージョン番号はこの対応になる。</a:t>
             </a:r>
           </a:p>
           <a:p>
@@ -21832,7 +21832,7 @@
                 <a:ea typeface="Noto Sans CJK JP"/>
                 <a:cs typeface="Noto Sans"/>
               </a:rPr>
-              <a:t>例えば銀行task_074のLight Blue口座は、無料引出しの条件に基づく返金額が8ドルから14.50ドルへ直された。</a:t>
+              <a:t>例えば銀行task_074のLight Blue口座は、無料引出しの条件に基づく返金額が8ドルから14.50ドルへ修正された。</a:t>
             </a:r>
           </a:p>
         </p:txBody>
@@ -24046,7 +24046,7 @@
                 <a:ea typeface="Noto Sans CJK JP"/>
                 <a:cs typeface="Noto Sans"/>
               </a:rPr>
-              <a:t>課題の内容：未発送の小さいTシャツを紫色へ変更する。サイズとVネックを保ち、素材はポリエステルを優先する。</a:t>
+              <a:t>課題の内容：Tシャツの選択肢数を確認し、未発送のSサイズTシャツを紫色に変更する。サイズとVネックを保ち、素材はポリエステルを優先する。</a:t>
             </a:r>
           </a:p>
         </p:txBody>
@@ -27880,7 +27880,7 @@
                           <a:ea typeface="Noto Sans CJK JP"/>
                           <a:cs typeface="Noto Sans"/>
                         </a:rPr>
-                        <a:t>1課題に含む不具合の数</a:t>
+                        <a:t>1課題に含まれる不具合の数</a:t>
                       </a:r>
                     </a:p>
                   </a:txBody>
@@ -28725,7 +28725,7 @@
                           <a:ea typeface="Noto Sans CJK JP"/>
                           <a:cs typeface="Noto Sans"/>
                         </a:rPr>
-                        <a:t>1課題に含む不具合の数</a:t>
+                        <a:t>1課題に含まれる不具合の数</a:t>
                       </a:r>
                     </a:p>
                   </a:txBody>
@@ -29608,7 +29608,7 @@
                     </a:bodyPr>
                     <a:lstStyle/>
                     <a:p>
-                      <a:pPr algn="r">
+                      <a:pPr algn="ctr">
                         <a:lnSpc>
                           <a:spcPts val="2070"/>
                         </a:lnSpc>
@@ -29664,7 +29664,7 @@
                     </a:bodyPr>
                     <a:lstStyle/>
                     <a:p>
-                      <a:pPr algn="r">
+                      <a:pPr algn="ctr">
                         <a:lnSpc>
                           <a:spcPts val="2070"/>
                         </a:lnSpc>
@@ -29720,7 +29720,7 @@
                     </a:bodyPr>
                     <a:lstStyle/>
                     <a:p>
-                      <a:pPr algn="l">
+                      <a:pPr algn="ctr">
                         <a:lnSpc>
                           <a:spcPts val="2070"/>
                         </a:lnSpc>
@@ -29776,7 +29776,7 @@
                     </a:bodyPr>
                     <a:lstStyle/>
                     <a:p>
-                      <a:pPr algn="l">
+                      <a:pPr algn="ctr">
                         <a:lnSpc>
                           <a:spcPts val="2070"/>
                         </a:lnSpc>
@@ -30665,7 +30665,7 @@
                 <a:ea typeface="Noto Sans CJK JP"/>
                 <a:cs typeface="Noto Sans"/>
               </a:rPr>
-              <a:t>通信の例：読取は契約情報や端末の状態を確認する。</a:t>
+              <a:t>通信の例：読取では契約情報や端末の状態を確認する。</a:t>
             </a:r>
           </a:p>
           <a:p>
@@ -35436,7 +35436,7 @@
                 <a:ea typeface="Noto Sans CJK JP"/>
                 <a:cs typeface="Noto Sans"/>
               </a:rPr>
-              <a:t>文書検索、業務ルールの適用、銀行の状態変更を組み合わせる評価を説明する。</a:t>
+              <a:t>文書検索、業務ルールの適用、銀行の状態変更を組み合わせた評価を説明する。</a:t>
             </a:r>
           </a:p>
           <a:p>
@@ -37161,7 +37161,7 @@
                 <a:ea typeface="Noto Sans CJK JP"/>
                 <a:cs typeface="Noto Sans"/>
               </a:rPr>
-              <a:t>課題の内容：キーボードとサーモスタットを交換する。キーの方式、照明、サイズ、対応するスマートホームの条件を満たす商品を探す。</a:t>
+              <a:t>課題の内容：キーボードとサーモスタットを交換する。キーの方式、バックライト、サイズ、対応するスマートホームの条件を満たす商品を探す。</a:t>
             </a:r>
           </a:p>
         </p:txBody>
@@ -37417,7 +37417,7 @@
                           <a:ea typeface="Noto Sans CJK JP"/>
                           <a:cs typeface="Noto Sans"/>
                         </a:rPr>
-                        <a:t>対象</a:t>
+                        <a:t>項目</a:t>
                       </a:r>
                     </a:p>
                   </a:txBody>

</xml_diff>